<commit_message>
submitting final project code
</commit_message>
<xml_diff>
--- a/FinalProj/FinalProj.pptx
+++ b/FinalProj/FinalProj.pptx
@@ -4,13 +4,23 @@
   <p:sldMasterIdLst>
     <p:sldMasterId id="2147483648" r:id="rId1"/>
   </p:sldMasterIdLst>
+  <p:notesMasterIdLst>
+    <p:notesMasterId r:id="rId15"/>
+  </p:notesMasterIdLst>
   <p:sldIdLst>
     <p:sldId id="256" r:id="rId2"/>
     <p:sldId id="260" r:id="rId3"/>
-    <p:sldId id="261" r:id="rId4"/>
-    <p:sldId id="257" r:id="rId5"/>
-    <p:sldId id="258" r:id="rId6"/>
-    <p:sldId id="259" r:id="rId7"/>
+    <p:sldId id="262" r:id="rId4"/>
+    <p:sldId id="261" r:id="rId5"/>
+    <p:sldId id="265" r:id="rId6"/>
+    <p:sldId id="263" r:id="rId7"/>
+    <p:sldId id="264" r:id="rId8"/>
+    <p:sldId id="266" r:id="rId9"/>
+    <p:sldId id="267" r:id="rId10"/>
+    <p:sldId id="257" r:id="rId11"/>
+    <p:sldId id="268" r:id="rId12"/>
+    <p:sldId id="259" r:id="rId13"/>
+    <p:sldId id="269" r:id="rId14"/>
   </p:sldIdLst>
   <p:sldSz cx="12192000" cy="6858000"/>
   <p:notesSz cx="6858000" cy="9144000"/>
@@ -109,7 +119,553 @@
       </a:defRPr>
     </a:lvl9pPr>
   </p:defaultTextStyle>
+  <p:extLst>
+    <p:ext uri="{EFAFB233-063F-42B5-8137-9DF3F51BA10A}">
+      <p15:sldGuideLst xmlns:p15="http://schemas.microsoft.com/office/powerpoint/2012/main"/>
+    </p:ext>
+  </p:extLst>
 </p:presentation>
+</file>
+
+<file path=ppt/notesMasters/notesMaster1.xml><?xml version="1.0" encoding="utf-8"?>
+<p:notesMaster xmlns:a="http://schemas.openxmlformats.org/drawingml/2006/main" xmlns:r="http://schemas.openxmlformats.org/officeDocument/2006/relationships" xmlns:p="http://schemas.openxmlformats.org/presentationml/2006/main">
+  <p:cSld>
+    <p:bg>
+      <p:bgRef idx="1001">
+        <a:schemeClr val="bg1"/>
+      </p:bgRef>
+    </p:bg>
+    <p:spTree>
+      <p:nvGrpSpPr>
+        <p:cNvPr id="1" name=""/>
+        <p:cNvGrpSpPr/>
+        <p:nvPr/>
+      </p:nvGrpSpPr>
+      <p:grpSpPr>
+        <a:xfrm>
+          <a:off x="0" y="0"/>
+          <a:ext cx="0" cy="0"/>
+          <a:chOff x="0" y="0"/>
+          <a:chExt cx="0" cy="0"/>
+        </a:xfrm>
+      </p:grpSpPr>
+      <p:sp>
+        <p:nvSpPr>
+          <p:cNvPr id="2" name="Header Placeholder 1"/>
+          <p:cNvSpPr>
+            <a:spLocks noGrp="1"/>
+          </p:cNvSpPr>
+          <p:nvPr>
+            <p:ph type="hdr" sz="quarter"/>
+          </p:nvPr>
+        </p:nvSpPr>
+        <p:spPr>
+          <a:xfrm>
+            <a:off x="0" y="0"/>
+            <a:ext cx="2971800" cy="458788"/>
+          </a:xfrm>
+          <a:prstGeom prst="rect">
+            <a:avLst/>
+          </a:prstGeom>
+        </p:spPr>
+        <p:txBody>
+          <a:bodyPr vert="horz" lIns="91440" tIns="45720" rIns="91440" bIns="45720" rtlCol="0"/>
+          <a:lstStyle>
+            <a:lvl1pPr algn="l">
+              <a:defRPr sz="1200"/>
+            </a:lvl1pPr>
+          </a:lstStyle>
+          <a:p>
+            <a:endParaRPr lang="en-US"/>
+          </a:p>
+        </p:txBody>
+      </p:sp>
+      <p:sp>
+        <p:nvSpPr>
+          <p:cNvPr id="3" name="Date Placeholder 2"/>
+          <p:cNvSpPr>
+            <a:spLocks noGrp="1"/>
+          </p:cNvSpPr>
+          <p:nvPr>
+            <p:ph type="dt" idx="1"/>
+          </p:nvPr>
+        </p:nvSpPr>
+        <p:spPr>
+          <a:xfrm>
+            <a:off x="3884613" y="0"/>
+            <a:ext cx="2971800" cy="458788"/>
+          </a:xfrm>
+          <a:prstGeom prst="rect">
+            <a:avLst/>
+          </a:prstGeom>
+        </p:spPr>
+        <p:txBody>
+          <a:bodyPr vert="horz" lIns="91440" tIns="45720" rIns="91440" bIns="45720" rtlCol="0"/>
+          <a:lstStyle>
+            <a:lvl1pPr algn="r">
+              <a:defRPr sz="1200"/>
+            </a:lvl1pPr>
+          </a:lstStyle>
+          <a:p>
+            <a:fld id="{80872B59-A535-49D4-ADCC-D5DD6C8FFC14}" type="datetimeFigureOut">
+              <a:rPr lang="en-US" smtClean="0"/>
+              <a:t>5/11/2026</a:t>
+            </a:fld>
+            <a:endParaRPr lang="en-US"/>
+          </a:p>
+        </p:txBody>
+      </p:sp>
+      <p:sp>
+        <p:nvSpPr>
+          <p:cNvPr id="4" name="Slide Image Placeholder 3"/>
+          <p:cNvSpPr>
+            <a:spLocks noGrp="1" noRot="1" noChangeAspect="1"/>
+          </p:cNvSpPr>
+          <p:nvPr>
+            <p:ph type="sldImg" idx="2"/>
+          </p:nvPr>
+        </p:nvSpPr>
+        <p:spPr>
+          <a:xfrm>
+            <a:off x="685800" y="1143000"/>
+            <a:ext cx="5486400" cy="3086100"/>
+          </a:xfrm>
+          <a:prstGeom prst="rect">
+            <a:avLst/>
+          </a:prstGeom>
+          <a:noFill/>
+          <a:ln w="12700">
+            <a:solidFill>
+              <a:prstClr val="black"/>
+            </a:solidFill>
+          </a:ln>
+        </p:spPr>
+        <p:txBody>
+          <a:bodyPr vert="horz" lIns="91440" tIns="45720" rIns="91440" bIns="45720" rtlCol="0" anchor="ctr"/>
+          <a:lstStyle/>
+          <a:p>
+            <a:endParaRPr lang="en-US"/>
+          </a:p>
+        </p:txBody>
+      </p:sp>
+      <p:sp>
+        <p:nvSpPr>
+          <p:cNvPr id="5" name="Notes Placeholder 4"/>
+          <p:cNvSpPr>
+            <a:spLocks noGrp="1"/>
+          </p:cNvSpPr>
+          <p:nvPr>
+            <p:ph type="body" sz="quarter" idx="3"/>
+          </p:nvPr>
+        </p:nvSpPr>
+        <p:spPr>
+          <a:xfrm>
+            <a:off x="685800" y="4400550"/>
+            <a:ext cx="5486400" cy="3600450"/>
+          </a:xfrm>
+          <a:prstGeom prst="rect">
+            <a:avLst/>
+          </a:prstGeom>
+        </p:spPr>
+        <p:txBody>
+          <a:bodyPr vert="horz" lIns="91440" tIns="45720" rIns="91440" bIns="45720" rtlCol="0"/>
+          <a:lstStyle/>
+          <a:p>
+            <a:pPr lvl="0"/>
+            <a:r>
+              <a:rPr lang="en-US"/>
+              <a:t>Click to edit Master text styles</a:t>
+            </a:r>
+          </a:p>
+          <a:p>
+            <a:pPr lvl="1"/>
+            <a:r>
+              <a:rPr lang="en-US"/>
+              <a:t>Second level</a:t>
+            </a:r>
+          </a:p>
+          <a:p>
+            <a:pPr lvl="2"/>
+            <a:r>
+              <a:rPr lang="en-US"/>
+              <a:t>Third level</a:t>
+            </a:r>
+          </a:p>
+          <a:p>
+            <a:pPr lvl="3"/>
+            <a:r>
+              <a:rPr lang="en-US"/>
+              <a:t>Fourth level</a:t>
+            </a:r>
+          </a:p>
+          <a:p>
+            <a:pPr lvl="4"/>
+            <a:r>
+              <a:rPr lang="en-US"/>
+              <a:t>Fifth level</a:t>
+            </a:r>
+          </a:p>
+        </p:txBody>
+      </p:sp>
+      <p:sp>
+        <p:nvSpPr>
+          <p:cNvPr id="6" name="Footer Placeholder 5"/>
+          <p:cNvSpPr>
+            <a:spLocks noGrp="1"/>
+          </p:cNvSpPr>
+          <p:nvPr>
+            <p:ph type="ftr" sz="quarter" idx="4"/>
+          </p:nvPr>
+        </p:nvSpPr>
+        <p:spPr>
+          <a:xfrm>
+            <a:off x="0" y="8685213"/>
+            <a:ext cx="2971800" cy="458787"/>
+          </a:xfrm>
+          <a:prstGeom prst="rect">
+            <a:avLst/>
+          </a:prstGeom>
+        </p:spPr>
+        <p:txBody>
+          <a:bodyPr vert="horz" lIns="91440" tIns="45720" rIns="91440" bIns="45720" rtlCol="0" anchor="b"/>
+          <a:lstStyle>
+            <a:lvl1pPr algn="l">
+              <a:defRPr sz="1200"/>
+            </a:lvl1pPr>
+          </a:lstStyle>
+          <a:p>
+            <a:endParaRPr lang="en-US"/>
+          </a:p>
+        </p:txBody>
+      </p:sp>
+      <p:sp>
+        <p:nvSpPr>
+          <p:cNvPr id="7" name="Slide Number Placeholder 6"/>
+          <p:cNvSpPr>
+            <a:spLocks noGrp="1"/>
+          </p:cNvSpPr>
+          <p:nvPr>
+            <p:ph type="sldNum" sz="quarter" idx="5"/>
+          </p:nvPr>
+        </p:nvSpPr>
+        <p:spPr>
+          <a:xfrm>
+            <a:off x="3884613" y="8685213"/>
+            <a:ext cx="2971800" cy="458787"/>
+          </a:xfrm>
+          <a:prstGeom prst="rect">
+            <a:avLst/>
+          </a:prstGeom>
+        </p:spPr>
+        <p:txBody>
+          <a:bodyPr vert="horz" lIns="91440" tIns="45720" rIns="91440" bIns="45720" rtlCol="0" anchor="b"/>
+          <a:lstStyle>
+            <a:lvl1pPr algn="r">
+              <a:defRPr sz="1200"/>
+            </a:lvl1pPr>
+          </a:lstStyle>
+          <a:p>
+            <a:fld id="{2C2759EE-1FCC-457B-97B3-9205F2DBBD49}" type="slidenum">
+              <a:rPr lang="en-US" smtClean="0"/>
+              <a:t>‹#›</a:t>
+            </a:fld>
+            <a:endParaRPr lang="en-US"/>
+          </a:p>
+        </p:txBody>
+      </p:sp>
+    </p:spTree>
+    <p:extLst>
+      <p:ext uri="{BB962C8B-B14F-4D97-AF65-F5344CB8AC3E}">
+        <p14:creationId xmlns:p14="http://schemas.microsoft.com/office/powerpoint/2010/main" val="2958310644"/>
+      </p:ext>
+    </p:extLst>
+  </p:cSld>
+  <p:clrMap bg1="lt1" tx1="dk1" bg2="lt2" tx2="dk2" accent1="accent1" accent2="accent2" accent3="accent3" accent4="accent4" accent5="accent5" accent6="accent6" hlink="hlink" folHlink="folHlink"/>
+  <p:notesStyle>
+    <a:lvl1pPr marL="0" algn="l" defTabSz="914400" rtl="0" eaLnBrk="1" latinLnBrk="0" hangingPunct="1">
+      <a:defRPr sz="1200" kern="1200">
+        <a:solidFill>
+          <a:schemeClr val="tx1"/>
+        </a:solidFill>
+        <a:latin typeface="+mn-lt"/>
+        <a:ea typeface="+mn-ea"/>
+        <a:cs typeface="+mn-cs"/>
+      </a:defRPr>
+    </a:lvl1pPr>
+    <a:lvl2pPr marL="457200" algn="l" defTabSz="914400" rtl="0" eaLnBrk="1" latinLnBrk="0" hangingPunct="1">
+      <a:defRPr sz="1200" kern="1200">
+        <a:solidFill>
+          <a:schemeClr val="tx1"/>
+        </a:solidFill>
+        <a:latin typeface="+mn-lt"/>
+        <a:ea typeface="+mn-ea"/>
+        <a:cs typeface="+mn-cs"/>
+      </a:defRPr>
+    </a:lvl2pPr>
+    <a:lvl3pPr marL="914400" algn="l" defTabSz="914400" rtl="0" eaLnBrk="1" latinLnBrk="0" hangingPunct="1">
+      <a:defRPr sz="1200" kern="1200">
+        <a:solidFill>
+          <a:schemeClr val="tx1"/>
+        </a:solidFill>
+        <a:latin typeface="+mn-lt"/>
+        <a:ea typeface="+mn-ea"/>
+        <a:cs typeface="+mn-cs"/>
+      </a:defRPr>
+    </a:lvl3pPr>
+    <a:lvl4pPr marL="1371600" algn="l" defTabSz="914400" rtl="0" eaLnBrk="1" latinLnBrk="0" hangingPunct="1">
+      <a:defRPr sz="1200" kern="1200">
+        <a:solidFill>
+          <a:schemeClr val="tx1"/>
+        </a:solidFill>
+        <a:latin typeface="+mn-lt"/>
+        <a:ea typeface="+mn-ea"/>
+        <a:cs typeface="+mn-cs"/>
+      </a:defRPr>
+    </a:lvl4pPr>
+    <a:lvl5pPr marL="1828800" algn="l" defTabSz="914400" rtl="0" eaLnBrk="1" latinLnBrk="0" hangingPunct="1">
+      <a:defRPr sz="1200" kern="1200">
+        <a:solidFill>
+          <a:schemeClr val="tx1"/>
+        </a:solidFill>
+        <a:latin typeface="+mn-lt"/>
+        <a:ea typeface="+mn-ea"/>
+        <a:cs typeface="+mn-cs"/>
+      </a:defRPr>
+    </a:lvl5pPr>
+    <a:lvl6pPr marL="2286000" algn="l" defTabSz="914400" rtl="0" eaLnBrk="1" latinLnBrk="0" hangingPunct="1">
+      <a:defRPr sz="1200" kern="1200">
+        <a:solidFill>
+          <a:schemeClr val="tx1"/>
+        </a:solidFill>
+        <a:latin typeface="+mn-lt"/>
+        <a:ea typeface="+mn-ea"/>
+        <a:cs typeface="+mn-cs"/>
+      </a:defRPr>
+    </a:lvl6pPr>
+    <a:lvl7pPr marL="2743200" algn="l" defTabSz="914400" rtl="0" eaLnBrk="1" latinLnBrk="0" hangingPunct="1">
+      <a:defRPr sz="1200" kern="1200">
+        <a:solidFill>
+          <a:schemeClr val="tx1"/>
+        </a:solidFill>
+        <a:latin typeface="+mn-lt"/>
+        <a:ea typeface="+mn-ea"/>
+        <a:cs typeface="+mn-cs"/>
+      </a:defRPr>
+    </a:lvl7pPr>
+    <a:lvl8pPr marL="3200400" algn="l" defTabSz="914400" rtl="0" eaLnBrk="1" latinLnBrk="0" hangingPunct="1">
+      <a:defRPr sz="1200" kern="1200">
+        <a:solidFill>
+          <a:schemeClr val="tx1"/>
+        </a:solidFill>
+        <a:latin typeface="+mn-lt"/>
+        <a:ea typeface="+mn-ea"/>
+        <a:cs typeface="+mn-cs"/>
+      </a:defRPr>
+    </a:lvl8pPr>
+    <a:lvl9pPr marL="3657600" algn="l" defTabSz="914400" rtl="0" eaLnBrk="1" latinLnBrk="0" hangingPunct="1">
+      <a:defRPr sz="1200" kern="1200">
+        <a:solidFill>
+          <a:schemeClr val="tx1"/>
+        </a:solidFill>
+        <a:latin typeface="+mn-lt"/>
+        <a:ea typeface="+mn-ea"/>
+        <a:cs typeface="+mn-cs"/>
+      </a:defRPr>
+    </a:lvl9pPr>
+  </p:notesStyle>
+</p:notesMaster>
+</file>
+
+<file path=ppt/notesSlides/notesSlide1.xml><?xml version="1.0" encoding="utf-8"?>
+<p:notes xmlns:a="http://schemas.openxmlformats.org/drawingml/2006/main" xmlns:r="http://schemas.openxmlformats.org/officeDocument/2006/relationships" xmlns:p="http://schemas.openxmlformats.org/presentationml/2006/main">
+  <p:cSld>
+    <p:spTree>
+      <p:nvGrpSpPr>
+        <p:cNvPr id="1" name=""/>
+        <p:cNvGrpSpPr/>
+        <p:nvPr/>
+      </p:nvGrpSpPr>
+      <p:grpSpPr>
+        <a:xfrm>
+          <a:off x="0" y="0"/>
+          <a:ext cx="0" cy="0"/>
+          <a:chOff x="0" y="0"/>
+          <a:chExt cx="0" cy="0"/>
+        </a:xfrm>
+      </p:grpSpPr>
+      <p:sp>
+        <p:nvSpPr>
+          <p:cNvPr id="2" name="Slide Image Placeholder 1"/>
+          <p:cNvSpPr>
+            <a:spLocks noGrp="1" noRot="1" noChangeAspect="1"/>
+          </p:cNvSpPr>
+          <p:nvPr>
+            <p:ph type="sldImg"/>
+          </p:nvPr>
+        </p:nvSpPr>
+        <p:spPr/>
+      </p:sp>
+      <p:sp>
+        <p:nvSpPr>
+          <p:cNvPr id="3" name="Notes Placeholder 2"/>
+          <p:cNvSpPr>
+            <a:spLocks noGrp="1"/>
+          </p:cNvSpPr>
+          <p:nvPr>
+            <p:ph type="body" idx="1"/>
+          </p:nvPr>
+        </p:nvSpPr>
+        <p:spPr/>
+        <p:txBody>
+          <a:bodyPr/>
+          <a:lstStyle/>
+          <a:p>
+            <a:endParaRPr lang="en-US" dirty="0"/>
+          </a:p>
+        </p:txBody>
+      </p:sp>
+      <p:sp>
+        <p:nvSpPr>
+          <p:cNvPr id="4" name="Slide Number Placeholder 3"/>
+          <p:cNvSpPr>
+            <a:spLocks noGrp="1"/>
+          </p:cNvSpPr>
+          <p:nvPr>
+            <p:ph type="sldNum" sz="quarter" idx="5"/>
+          </p:nvPr>
+        </p:nvSpPr>
+        <p:spPr/>
+        <p:txBody>
+          <a:bodyPr/>
+          <a:lstStyle/>
+          <a:p>
+            <a:fld id="{2C2759EE-1FCC-457B-97B3-9205F2DBBD49}" type="slidenum">
+              <a:rPr lang="en-US" smtClean="0"/>
+              <a:t>10</a:t>
+            </a:fld>
+            <a:endParaRPr lang="en-US"/>
+          </a:p>
+        </p:txBody>
+      </p:sp>
+    </p:spTree>
+    <p:extLst>
+      <p:ext uri="{BB962C8B-B14F-4D97-AF65-F5344CB8AC3E}">
+        <p14:creationId xmlns:p14="http://schemas.microsoft.com/office/powerpoint/2010/main" val="3817336710"/>
+      </p:ext>
+    </p:extLst>
+  </p:cSld>
+  <p:clrMapOvr>
+    <a:masterClrMapping/>
+  </p:clrMapOvr>
+</p:notes>
+</file>
+
+<file path=ppt/notesSlides/notesSlide2.xml><?xml version="1.0" encoding="utf-8"?>
+<p:notes xmlns:a="http://schemas.openxmlformats.org/drawingml/2006/main" xmlns:r="http://schemas.openxmlformats.org/officeDocument/2006/relationships" xmlns:p="http://schemas.openxmlformats.org/presentationml/2006/main">
+  <p:cSld>
+    <p:spTree>
+      <p:nvGrpSpPr>
+        <p:cNvPr id="1" name="">
+          <a:extLst>
+            <a:ext uri="{FF2B5EF4-FFF2-40B4-BE49-F238E27FC236}">
+              <a16:creationId xmlns:a16="http://schemas.microsoft.com/office/drawing/2014/main" id="{5094C606-4915-12A6-2F3E-1F84B4FAB6FE}"/>
+            </a:ext>
+          </a:extLst>
+        </p:cNvPr>
+        <p:cNvGrpSpPr/>
+        <p:nvPr/>
+      </p:nvGrpSpPr>
+      <p:grpSpPr>
+        <a:xfrm>
+          <a:off x="0" y="0"/>
+          <a:ext cx="0" cy="0"/>
+          <a:chOff x="0" y="0"/>
+          <a:chExt cx="0" cy="0"/>
+        </a:xfrm>
+      </p:grpSpPr>
+      <p:sp>
+        <p:nvSpPr>
+          <p:cNvPr id="2" name="Slide Image Placeholder 1">
+            <a:extLst>
+              <a:ext uri="{FF2B5EF4-FFF2-40B4-BE49-F238E27FC236}">
+                <a16:creationId xmlns:a16="http://schemas.microsoft.com/office/drawing/2014/main" id="{B59C224D-A38B-F9AD-0102-2A982F739F2D}"/>
+              </a:ext>
+            </a:extLst>
+          </p:cNvPr>
+          <p:cNvSpPr>
+            <a:spLocks noGrp="1" noRot="1" noChangeAspect="1"/>
+          </p:cNvSpPr>
+          <p:nvPr>
+            <p:ph type="sldImg"/>
+          </p:nvPr>
+        </p:nvSpPr>
+        <p:spPr/>
+      </p:sp>
+      <p:sp>
+        <p:nvSpPr>
+          <p:cNvPr id="3" name="Notes Placeholder 2">
+            <a:extLst>
+              <a:ext uri="{FF2B5EF4-FFF2-40B4-BE49-F238E27FC236}">
+                <a16:creationId xmlns:a16="http://schemas.microsoft.com/office/drawing/2014/main" id="{FB29BE2E-8DBA-7B24-D705-7E398BF16E45}"/>
+              </a:ext>
+            </a:extLst>
+          </p:cNvPr>
+          <p:cNvSpPr>
+            <a:spLocks noGrp="1"/>
+          </p:cNvSpPr>
+          <p:nvPr>
+            <p:ph type="body" idx="1"/>
+          </p:nvPr>
+        </p:nvSpPr>
+        <p:spPr/>
+        <p:txBody>
+          <a:bodyPr/>
+          <a:lstStyle/>
+          <a:p>
+            <a:endParaRPr lang="en-US" dirty="0"/>
+          </a:p>
+        </p:txBody>
+      </p:sp>
+      <p:sp>
+        <p:nvSpPr>
+          <p:cNvPr id="4" name="Slide Number Placeholder 3">
+            <a:extLst>
+              <a:ext uri="{FF2B5EF4-FFF2-40B4-BE49-F238E27FC236}">
+                <a16:creationId xmlns:a16="http://schemas.microsoft.com/office/drawing/2014/main" id="{4AC81D07-5C14-99C2-1BB7-69BBD175DD03}"/>
+              </a:ext>
+            </a:extLst>
+          </p:cNvPr>
+          <p:cNvSpPr>
+            <a:spLocks noGrp="1"/>
+          </p:cNvSpPr>
+          <p:nvPr>
+            <p:ph type="sldNum" sz="quarter" idx="5"/>
+          </p:nvPr>
+        </p:nvSpPr>
+        <p:spPr/>
+        <p:txBody>
+          <a:bodyPr/>
+          <a:lstStyle/>
+          <a:p>
+            <a:fld id="{2C2759EE-1FCC-457B-97B3-9205F2DBBD49}" type="slidenum">
+              <a:rPr lang="en-US" smtClean="0"/>
+              <a:t>11</a:t>
+            </a:fld>
+            <a:endParaRPr lang="en-US"/>
+          </a:p>
+        </p:txBody>
+      </p:sp>
+    </p:spTree>
+    <p:extLst>
+      <p:ext uri="{BB962C8B-B14F-4D97-AF65-F5344CB8AC3E}">
+        <p14:creationId xmlns:p14="http://schemas.microsoft.com/office/powerpoint/2010/main" val="3094395137"/>
+      </p:ext>
+    </p:extLst>
+  </p:cSld>
+  <p:clrMapOvr>
+    <a:masterClrMapping/>
+  </p:clrMapOvr>
+</p:notes>
 </file>
 
 <file path=ppt/slideLayouts/slideLayout1.xml><?xml version="1.0" encoding="utf-8"?>
@@ -259,7 +815,7 @@
           <a:p>
             <a:fld id="{F2D161E5-5842-431F-BF15-93C1CF6FA822}" type="datetimeFigureOut">
               <a:rPr lang="en-US" smtClean="0"/>
-              <a:t>5/10/2026</a:t>
+              <a:t>5/11/2026</a:t>
             </a:fld>
             <a:endParaRPr lang="en-US"/>
           </a:p>
@@ -457,7 +1013,7 @@
           <a:p>
             <a:fld id="{F2D161E5-5842-431F-BF15-93C1CF6FA822}" type="datetimeFigureOut">
               <a:rPr lang="en-US" smtClean="0"/>
-              <a:t>5/10/2026</a:t>
+              <a:t>5/11/2026</a:t>
             </a:fld>
             <a:endParaRPr lang="en-US"/>
           </a:p>
@@ -665,7 +1221,7 @@
           <a:p>
             <a:fld id="{F2D161E5-5842-431F-BF15-93C1CF6FA822}" type="datetimeFigureOut">
               <a:rPr lang="en-US" smtClean="0"/>
-              <a:t>5/10/2026</a:t>
+              <a:t>5/11/2026</a:t>
             </a:fld>
             <a:endParaRPr lang="en-US"/>
           </a:p>
@@ -863,7 +1419,7 @@
           <a:p>
             <a:fld id="{F2D161E5-5842-431F-BF15-93C1CF6FA822}" type="datetimeFigureOut">
               <a:rPr lang="en-US" smtClean="0"/>
-              <a:t>5/10/2026</a:t>
+              <a:t>5/11/2026</a:t>
             </a:fld>
             <a:endParaRPr lang="en-US"/>
           </a:p>
@@ -1138,7 +1694,7 @@
           <a:p>
             <a:fld id="{F2D161E5-5842-431F-BF15-93C1CF6FA822}" type="datetimeFigureOut">
               <a:rPr lang="en-US" smtClean="0"/>
-              <a:t>5/10/2026</a:t>
+              <a:t>5/11/2026</a:t>
             </a:fld>
             <a:endParaRPr lang="en-US"/>
           </a:p>
@@ -1403,7 +1959,7 @@
           <a:p>
             <a:fld id="{F2D161E5-5842-431F-BF15-93C1CF6FA822}" type="datetimeFigureOut">
               <a:rPr lang="en-US" smtClean="0"/>
-              <a:t>5/10/2026</a:t>
+              <a:t>5/11/2026</a:t>
             </a:fld>
             <a:endParaRPr lang="en-US"/>
           </a:p>
@@ -1815,7 +2371,7 @@
           <a:p>
             <a:fld id="{F2D161E5-5842-431F-BF15-93C1CF6FA822}" type="datetimeFigureOut">
               <a:rPr lang="en-US" smtClean="0"/>
-              <a:t>5/10/2026</a:t>
+              <a:t>5/11/2026</a:t>
             </a:fld>
             <a:endParaRPr lang="en-US"/>
           </a:p>
@@ -1956,7 +2512,7 @@
           <a:p>
             <a:fld id="{F2D161E5-5842-431F-BF15-93C1CF6FA822}" type="datetimeFigureOut">
               <a:rPr lang="en-US" smtClean="0"/>
-              <a:t>5/10/2026</a:t>
+              <a:t>5/11/2026</a:t>
             </a:fld>
             <a:endParaRPr lang="en-US"/>
           </a:p>
@@ -2069,7 +2625,7 @@
           <a:p>
             <a:fld id="{F2D161E5-5842-431F-BF15-93C1CF6FA822}" type="datetimeFigureOut">
               <a:rPr lang="en-US" smtClean="0"/>
-              <a:t>5/10/2026</a:t>
+              <a:t>5/11/2026</a:t>
             </a:fld>
             <a:endParaRPr lang="en-US"/>
           </a:p>
@@ -2380,7 +2936,7 @@
           <a:p>
             <a:fld id="{F2D161E5-5842-431F-BF15-93C1CF6FA822}" type="datetimeFigureOut">
               <a:rPr lang="en-US" smtClean="0"/>
-              <a:t>5/10/2026</a:t>
+              <a:t>5/11/2026</a:t>
             </a:fld>
             <a:endParaRPr lang="en-US"/>
           </a:p>
@@ -2668,7 +3224,7 @@
           <a:p>
             <a:fld id="{F2D161E5-5842-431F-BF15-93C1CF6FA822}" type="datetimeFigureOut">
               <a:rPr lang="en-US" smtClean="0"/>
-              <a:t>5/10/2026</a:t>
+              <a:t>5/11/2026</a:t>
             </a:fld>
             <a:endParaRPr lang="en-US"/>
           </a:p>
@@ -2909,7 +3465,7 @@
           <a:p>
             <a:fld id="{F2D161E5-5842-431F-BF15-93C1CF6FA822}" type="datetimeFigureOut">
               <a:rPr lang="en-US" smtClean="0"/>
-              <a:t>5/10/2026</a:t>
+              <a:t>5/11/2026</a:t>
             </a:fld>
             <a:endParaRPr lang="en-US"/>
           </a:p>
@@ -3350,15 +3906,8 @@
           <a:lstStyle/>
           <a:p>
             <a:r>
-              <a:rPr lang="en-US" dirty="0" err="1"/>
-              <a:t>BullDussSee</a:t>
-            </a:r>
-            <a:br>
               <a:rPr lang="en-US" dirty="0"/>
-            </a:br>
-            <a:r>
-              <a:rPr lang="en-US" dirty="0"/>
-              <a:t>real-time position and velocity control of a brushless DC motor</a:t>
+              <a:t>Real-Time Position and Velocity Control of a Brushless DC Motor</a:t>
             </a:r>
           </a:p>
         </p:txBody>
@@ -3387,6 +3936,12 @@
             <a:r>
               <a:rPr lang="en-US" dirty="0"/>
               <a:t>Romeo Perlstein</a:t>
+            </a:r>
+          </a:p>
+          <a:p>
+            <a:r>
+              <a:rPr lang="en-US" dirty="0"/>
+              <a:t>ENPM818J Final Project</a:t>
             </a:r>
           </a:p>
         </p:txBody>
@@ -3395,6 +3950,764 @@
     <p:extLst>
       <p:ext uri="{BB962C8B-B14F-4D97-AF65-F5344CB8AC3E}">
         <p14:creationId xmlns:p14="http://schemas.microsoft.com/office/powerpoint/2010/main" val="2930359113"/>
+      </p:ext>
+    </p:extLst>
+  </p:cSld>
+  <p:clrMapOvr>
+    <a:masterClrMapping/>
+  </p:clrMapOvr>
+</p:sld>
+</file>
+
+<file path=ppt/slides/slide10.xml><?xml version="1.0" encoding="utf-8"?>
+<p:sld xmlns:a="http://schemas.openxmlformats.org/drawingml/2006/main" xmlns:r="http://schemas.openxmlformats.org/officeDocument/2006/relationships" xmlns:p="http://schemas.openxmlformats.org/presentationml/2006/main">
+  <p:cSld>
+    <p:spTree>
+      <p:nvGrpSpPr>
+        <p:cNvPr id="1" name=""/>
+        <p:cNvGrpSpPr/>
+        <p:nvPr/>
+      </p:nvGrpSpPr>
+      <p:grpSpPr>
+        <a:xfrm>
+          <a:off x="0" y="0"/>
+          <a:ext cx="0" cy="0"/>
+          <a:chOff x="0" y="0"/>
+          <a:chExt cx="0" cy="0"/>
+        </a:xfrm>
+      </p:grpSpPr>
+      <p:sp>
+        <p:nvSpPr>
+          <p:cNvPr id="2" name="Title 1">
+            <a:extLst>
+              <a:ext uri="{FF2B5EF4-FFF2-40B4-BE49-F238E27FC236}">
+                <a16:creationId xmlns:a16="http://schemas.microsoft.com/office/drawing/2014/main" id="{38A5C4F5-8582-133D-4862-EA39B80ADEAF}"/>
+              </a:ext>
+            </a:extLst>
+          </p:cNvPr>
+          <p:cNvSpPr>
+            <a:spLocks noGrp="1"/>
+          </p:cNvSpPr>
+          <p:nvPr>
+            <p:ph type="title"/>
+          </p:nvPr>
+        </p:nvSpPr>
+        <p:spPr/>
+        <p:txBody>
+          <a:bodyPr/>
+          <a:lstStyle/>
+          <a:p>
+            <a:r>
+              <a:rPr lang="en-US" dirty="0"/>
+              <a:t>Core Components</a:t>
+            </a:r>
+          </a:p>
+        </p:txBody>
+      </p:sp>
+      <p:sp>
+        <p:nvSpPr>
+          <p:cNvPr id="3" name="Content Placeholder 2">
+            <a:extLst>
+              <a:ext uri="{FF2B5EF4-FFF2-40B4-BE49-F238E27FC236}">
+                <a16:creationId xmlns:a16="http://schemas.microsoft.com/office/drawing/2014/main" id="{49CE2960-59CD-DF9C-733E-C6EF63E86DDC}"/>
+              </a:ext>
+            </a:extLst>
+          </p:cNvPr>
+          <p:cNvSpPr>
+            <a:spLocks noGrp="1"/>
+          </p:cNvSpPr>
+          <p:nvPr>
+            <p:ph idx="1"/>
+          </p:nvPr>
+        </p:nvSpPr>
+        <p:spPr>
+          <a:xfrm>
+            <a:off x="838200" y="1825625"/>
+            <a:ext cx="8539480" cy="4351338"/>
+          </a:xfrm>
+        </p:spPr>
+        <p:txBody>
+          <a:bodyPr/>
+          <a:lstStyle/>
+          <a:p>
+            <a:r>
+              <a:rPr lang="en-US" dirty="0" err="1"/>
+              <a:t>RioRand</a:t>
+            </a:r>
+            <a:r>
+              <a:rPr lang="en-US" dirty="0"/>
+              <a:t> 3-Phase Brushless DC motor driver with PWM input</a:t>
+            </a:r>
+          </a:p>
+          <a:p>
+            <a:r>
+              <a:rPr lang="en-US" dirty="0"/>
+              <a:t>Hoverboard motor </a:t>
+            </a:r>
+          </a:p>
+          <a:p>
+            <a:r>
+              <a:rPr lang="en-US" dirty="0"/>
+              <a:t>1515 80/20 extrusion</a:t>
+            </a:r>
+          </a:p>
+          <a:p>
+            <a:endParaRPr lang="en-US" dirty="0"/>
+          </a:p>
+          <a:p>
+            <a:r>
+              <a:rPr lang="en-US" dirty="0"/>
+              <a:t>ESP32 WROOM</a:t>
+            </a:r>
+          </a:p>
+          <a:p>
+            <a:r>
+              <a:rPr lang="en-US" dirty="0"/>
+              <a:t>Quadrature Encoder</a:t>
+            </a:r>
+          </a:p>
+        </p:txBody>
+      </p:sp>
+      <p:pic>
+        <p:nvPicPr>
+          <p:cNvPr id="4" name="Picture 3">
+            <a:extLst>
+              <a:ext uri="{FF2B5EF4-FFF2-40B4-BE49-F238E27FC236}">
+                <a16:creationId xmlns:a16="http://schemas.microsoft.com/office/drawing/2014/main" id="{E72D71F3-277B-21FB-06B6-199E55010FD0}"/>
+              </a:ext>
+            </a:extLst>
+          </p:cNvPr>
+          <p:cNvPicPr>
+            <a:picLocks noChangeAspect="1"/>
+          </p:cNvPicPr>
+          <p:nvPr/>
+        </p:nvPicPr>
+        <p:blipFill>
+          <a:blip r:embed="rId3"/>
+          <a:stretch>
+            <a:fillRect/>
+          </a:stretch>
+        </p:blipFill>
+        <p:spPr>
+          <a:xfrm>
+            <a:off x="8909967" y="1249680"/>
+            <a:ext cx="2594651" cy="2250440"/>
+          </a:xfrm>
+          <a:prstGeom prst="rect">
+            <a:avLst/>
+          </a:prstGeom>
+        </p:spPr>
+      </p:pic>
+      <p:pic>
+        <p:nvPicPr>
+          <p:cNvPr id="5" name="Picture 4" descr="Amazon.com: 6.5 Inch Self Balancing Scooter Motor Wheel with Tire Self  Balance Unicycle Hover Board Motor Replacement : Sports &amp; Outdoors">
+            <a:extLst>
+              <a:ext uri="{FF2B5EF4-FFF2-40B4-BE49-F238E27FC236}">
+                <a16:creationId xmlns:a16="http://schemas.microsoft.com/office/drawing/2014/main" id="{7E5BA32F-2F11-FFF6-F223-AFB8D08C9C1C}"/>
+              </a:ext>
+            </a:extLst>
+          </p:cNvPr>
+          <p:cNvPicPr>
+            <a:picLocks noChangeAspect="1"/>
+          </p:cNvPicPr>
+          <p:nvPr/>
+        </p:nvPicPr>
+        <p:blipFill>
+          <a:blip r:embed="rId4"/>
+          <a:stretch>
+            <a:fillRect/>
+          </a:stretch>
+        </p:blipFill>
+        <p:spPr>
+          <a:xfrm>
+            <a:off x="6522027" y="2291008"/>
+            <a:ext cx="2027846" cy="1710286"/>
+          </a:xfrm>
+          <a:prstGeom prst="rect">
+            <a:avLst/>
+          </a:prstGeom>
+        </p:spPr>
+      </p:pic>
+      <p:pic>
+        <p:nvPicPr>
+          <p:cNvPr id="6" name="Picture 5" descr="1515-S | 1.50” X 1.50” Smooth Surface T-Slotted Profile - Four Open T-Slots">
+            <a:extLst>
+              <a:ext uri="{FF2B5EF4-FFF2-40B4-BE49-F238E27FC236}">
+                <a16:creationId xmlns:a16="http://schemas.microsoft.com/office/drawing/2014/main" id="{62400967-540C-7EC8-073E-56029B3B5DCD}"/>
+              </a:ext>
+            </a:extLst>
+          </p:cNvPr>
+          <p:cNvPicPr>
+            <a:picLocks noChangeAspect="1"/>
+          </p:cNvPicPr>
+          <p:nvPr/>
+        </p:nvPicPr>
+        <p:blipFill>
+          <a:blip r:embed="rId5"/>
+          <a:stretch>
+            <a:fillRect/>
+          </a:stretch>
+        </p:blipFill>
+        <p:spPr>
+          <a:xfrm>
+            <a:off x="4411745" y="2815242"/>
+            <a:ext cx="1743941" cy="1743941"/>
+          </a:xfrm>
+          <a:prstGeom prst="rect">
+            <a:avLst/>
+          </a:prstGeom>
+        </p:spPr>
+      </p:pic>
+      <p:pic>
+        <p:nvPicPr>
+          <p:cNvPr id="9" name="Picture 8" descr="Amazon.com: ESP32 Type-C Module ESP32 30PIN NodeMCU Development Board ESP32- WROOM-32 2.4 GHz WLAN CP-2102 : Electronics">
+            <a:extLst>
+              <a:ext uri="{FF2B5EF4-FFF2-40B4-BE49-F238E27FC236}">
+                <a16:creationId xmlns:a16="http://schemas.microsoft.com/office/drawing/2014/main" id="{0A48CF47-CE26-78BA-F050-DF0CEF1CAB67}"/>
+              </a:ext>
+            </a:extLst>
+          </p:cNvPr>
+          <p:cNvPicPr>
+            <a:picLocks noChangeAspect="1"/>
+          </p:cNvPicPr>
+          <p:nvPr/>
+        </p:nvPicPr>
+        <p:blipFill>
+          <a:blip r:embed="rId6"/>
+          <a:stretch>
+            <a:fillRect/>
+          </a:stretch>
+        </p:blipFill>
+        <p:spPr>
+          <a:xfrm>
+            <a:off x="7459952" y="3931092"/>
+            <a:ext cx="2236991" cy="1800724"/>
+          </a:xfrm>
+          <a:prstGeom prst="rect">
+            <a:avLst/>
+          </a:prstGeom>
+        </p:spPr>
+      </p:pic>
+      <p:pic>
+        <p:nvPicPr>
+          <p:cNvPr id="10" name="Picture 9" descr="Amazon.com: Taiss/AB 2 phase Incremental Rotary Encoder 360P/R DC 5-24v  Wide Voltage Power Supply 6mm Shaft 360P/R : Industrial &amp; Scientific">
+            <a:extLst>
+              <a:ext uri="{FF2B5EF4-FFF2-40B4-BE49-F238E27FC236}">
+                <a16:creationId xmlns:a16="http://schemas.microsoft.com/office/drawing/2014/main" id="{AA8BC0F4-4B2D-328A-7D38-A3F6836FBD91}"/>
+              </a:ext>
+            </a:extLst>
+          </p:cNvPr>
+          <p:cNvPicPr>
+            <a:picLocks noChangeAspect="1"/>
+          </p:cNvPicPr>
+          <p:nvPr/>
+        </p:nvPicPr>
+        <p:blipFill>
+          <a:blip r:embed="rId7"/>
+          <a:stretch>
+            <a:fillRect/>
+          </a:stretch>
+        </p:blipFill>
+        <p:spPr>
+          <a:xfrm>
+            <a:off x="4898967" y="4466677"/>
+            <a:ext cx="2194644" cy="2194644"/>
+          </a:xfrm>
+          <a:prstGeom prst="rect">
+            <a:avLst/>
+          </a:prstGeom>
+        </p:spPr>
+      </p:pic>
+    </p:spTree>
+    <p:extLst>
+      <p:ext uri="{BB962C8B-B14F-4D97-AF65-F5344CB8AC3E}">
+        <p14:creationId xmlns:p14="http://schemas.microsoft.com/office/powerpoint/2010/main" val="1566628785"/>
+      </p:ext>
+    </p:extLst>
+  </p:cSld>
+  <p:clrMapOvr>
+    <a:masterClrMapping/>
+  </p:clrMapOvr>
+</p:sld>
+</file>
+
+<file path=ppt/slides/slide11.xml><?xml version="1.0" encoding="utf-8"?>
+<p:sld xmlns:a="http://schemas.openxmlformats.org/drawingml/2006/main" xmlns:r="http://schemas.openxmlformats.org/officeDocument/2006/relationships" xmlns:p="http://schemas.openxmlformats.org/presentationml/2006/main">
+  <p:cSld>
+    <p:spTree>
+      <p:nvGrpSpPr>
+        <p:cNvPr id="1" name="">
+          <a:extLst>
+            <a:ext uri="{FF2B5EF4-FFF2-40B4-BE49-F238E27FC236}">
+              <a16:creationId xmlns:a16="http://schemas.microsoft.com/office/drawing/2014/main" id="{EA05AE20-9E6A-BE17-E493-CFEF62ACAAD4}"/>
+            </a:ext>
+          </a:extLst>
+        </p:cNvPr>
+        <p:cNvGrpSpPr/>
+        <p:nvPr/>
+      </p:nvGrpSpPr>
+      <p:grpSpPr>
+        <a:xfrm>
+          <a:off x="0" y="0"/>
+          <a:ext cx="0" cy="0"/>
+          <a:chOff x="0" y="0"/>
+          <a:chExt cx="0" cy="0"/>
+        </a:xfrm>
+      </p:grpSpPr>
+      <p:sp>
+        <p:nvSpPr>
+          <p:cNvPr id="2" name="Title 1">
+            <a:extLst>
+              <a:ext uri="{FF2B5EF4-FFF2-40B4-BE49-F238E27FC236}">
+                <a16:creationId xmlns:a16="http://schemas.microsoft.com/office/drawing/2014/main" id="{2C7FFC26-0F1B-13DC-BFCC-4CCF47E61E9F}"/>
+              </a:ext>
+            </a:extLst>
+          </p:cNvPr>
+          <p:cNvSpPr>
+            <a:spLocks noGrp="1"/>
+          </p:cNvSpPr>
+          <p:nvPr>
+            <p:ph type="title"/>
+          </p:nvPr>
+        </p:nvSpPr>
+        <p:spPr/>
+        <p:txBody>
+          <a:bodyPr/>
+          <a:lstStyle/>
+          <a:p>
+            <a:r>
+              <a:rPr lang="en-US" dirty="0"/>
+              <a:t>Additional Components</a:t>
+            </a:r>
+          </a:p>
+        </p:txBody>
+      </p:sp>
+      <p:sp>
+        <p:nvSpPr>
+          <p:cNvPr id="3" name="Content Placeholder 2">
+            <a:extLst>
+              <a:ext uri="{FF2B5EF4-FFF2-40B4-BE49-F238E27FC236}">
+                <a16:creationId xmlns:a16="http://schemas.microsoft.com/office/drawing/2014/main" id="{C1EA080B-F3EF-820E-586B-8F585868C67A}"/>
+              </a:ext>
+            </a:extLst>
+          </p:cNvPr>
+          <p:cNvSpPr>
+            <a:spLocks noGrp="1"/>
+          </p:cNvSpPr>
+          <p:nvPr>
+            <p:ph idx="1"/>
+          </p:nvPr>
+        </p:nvSpPr>
+        <p:spPr>
+          <a:xfrm>
+            <a:off x="838200" y="1825625"/>
+            <a:ext cx="8539480" cy="4351338"/>
+          </a:xfrm>
+        </p:spPr>
+        <p:txBody>
+          <a:bodyPr/>
+          <a:lstStyle/>
+          <a:p>
+            <a:r>
+              <a:rPr lang="en-US" dirty="0"/>
+              <a:t>WAGO lever-lock connectors</a:t>
+            </a:r>
+          </a:p>
+          <a:p>
+            <a:r>
+              <a:rPr lang="en-US" dirty="0"/>
+              <a:t>Breadboard</a:t>
+            </a:r>
+          </a:p>
+          <a:p>
+            <a:r>
+              <a:rPr lang="en-US" dirty="0"/>
+              <a:t>30V-10A power supply</a:t>
+            </a:r>
+          </a:p>
+          <a:p>
+            <a:r>
+              <a:rPr lang="en-US" dirty="0"/>
+              <a:t>Enable/disable switch</a:t>
+            </a:r>
+          </a:p>
+          <a:p>
+            <a:r>
+              <a:rPr lang="en-US" dirty="0"/>
+              <a:t>Potentiometer</a:t>
+            </a:r>
+          </a:p>
+          <a:p>
+            <a:r>
+              <a:rPr lang="en-US" dirty="0"/>
+              <a:t>C-clamp</a:t>
+            </a:r>
+          </a:p>
+          <a:p>
+            <a:endParaRPr lang="en-US" dirty="0"/>
+          </a:p>
+        </p:txBody>
+      </p:sp>
+      <p:pic>
+        <p:nvPicPr>
+          <p:cNvPr id="7" name="Picture 6" descr="Amazon.com: 221-413 | WAGO Lever-Nuts® Splicing Connector | for Solid and  Stranded Conductors | 3-Conductor with Operating levers | 24-12 AWG |  Transparent housing | [Box of 50 Pieces] : Industrial &amp; Scientific">
+            <a:extLst>
+              <a:ext uri="{FF2B5EF4-FFF2-40B4-BE49-F238E27FC236}">
+                <a16:creationId xmlns:a16="http://schemas.microsoft.com/office/drawing/2014/main" id="{27721529-6FEC-C38A-16C0-FFC8FC453CB8}"/>
+              </a:ext>
+            </a:extLst>
+          </p:cNvPr>
+          <p:cNvPicPr>
+            <a:picLocks noChangeAspect="1"/>
+          </p:cNvPicPr>
+          <p:nvPr/>
+        </p:nvPicPr>
+        <p:blipFill>
+          <a:blip r:embed="rId3"/>
+          <a:stretch>
+            <a:fillRect/>
+          </a:stretch>
+        </p:blipFill>
+        <p:spPr>
+          <a:xfrm>
+            <a:off x="5864772" y="1333335"/>
+            <a:ext cx="2937805" cy="2937805"/>
+          </a:xfrm>
+          <a:prstGeom prst="rect">
+            <a:avLst/>
+          </a:prstGeom>
+        </p:spPr>
+      </p:pic>
+      <p:pic>
+        <p:nvPicPr>
+          <p:cNvPr id="8" name="Picture 7" descr="BESSEY CM Series 6 in. Capacity Drop Forged C-Clamp with 3-1/2 in. Throat  Depth CM60 - The Home Depot">
+            <a:extLst>
+              <a:ext uri="{FF2B5EF4-FFF2-40B4-BE49-F238E27FC236}">
+                <a16:creationId xmlns:a16="http://schemas.microsoft.com/office/drawing/2014/main" id="{A22E187F-DCDF-3851-235C-20BFF818040C}"/>
+              </a:ext>
+            </a:extLst>
+          </p:cNvPr>
+          <p:cNvPicPr>
+            <a:picLocks noChangeAspect="1"/>
+          </p:cNvPicPr>
+          <p:nvPr/>
+        </p:nvPicPr>
+        <p:blipFill>
+          <a:blip r:embed="rId4"/>
+          <a:stretch>
+            <a:fillRect/>
+          </a:stretch>
+        </p:blipFill>
+        <p:spPr>
+          <a:xfrm>
+            <a:off x="4478721" y="3969406"/>
+            <a:ext cx="2342494" cy="2342494"/>
+          </a:xfrm>
+          <a:prstGeom prst="rect">
+            <a:avLst/>
+          </a:prstGeom>
+        </p:spPr>
+      </p:pic>
+      <p:pic>
+        <p:nvPicPr>
+          <p:cNvPr id="11" name="Picture 10" descr="Amazon.com: PACUM Variable DC Power Supply Adjustable DC Power Supply 30V  10A 60V5A Lab Bench Power Supply Laboratory Stabilized Power Supply Voltage  Regulator Switch Power Supply Adjustable(Red Display 30V10A) : Industrial &amp;">
+            <a:extLst>
+              <a:ext uri="{FF2B5EF4-FFF2-40B4-BE49-F238E27FC236}">
+                <a16:creationId xmlns:a16="http://schemas.microsoft.com/office/drawing/2014/main" id="{3D063BBA-B3C1-78AC-1DEC-5D25B3310844}"/>
+              </a:ext>
+            </a:extLst>
+          </p:cNvPr>
+          <p:cNvPicPr>
+            <a:picLocks noChangeAspect="1"/>
+          </p:cNvPicPr>
+          <p:nvPr/>
+        </p:nvPicPr>
+        <p:blipFill>
+          <a:blip r:embed="rId5"/>
+          <a:stretch>
+            <a:fillRect/>
+          </a:stretch>
+        </p:blipFill>
+        <p:spPr>
+          <a:xfrm>
+            <a:off x="8080797" y="3429000"/>
+            <a:ext cx="3168869" cy="3168869"/>
+          </a:xfrm>
+          <a:prstGeom prst="rect">
+            <a:avLst/>
+          </a:prstGeom>
+        </p:spPr>
+      </p:pic>
+    </p:spTree>
+    <p:extLst>
+      <p:ext uri="{BB962C8B-B14F-4D97-AF65-F5344CB8AC3E}">
+        <p14:creationId xmlns:p14="http://schemas.microsoft.com/office/powerpoint/2010/main" val="1715174826"/>
+      </p:ext>
+    </p:extLst>
+  </p:cSld>
+  <p:clrMapOvr>
+    <a:masterClrMapping/>
+  </p:clrMapOvr>
+</p:sld>
+</file>
+
+<file path=ppt/slides/slide12.xml><?xml version="1.0" encoding="utf-8"?>
+<p:sld xmlns:a="http://schemas.openxmlformats.org/drawingml/2006/main" xmlns:r="http://schemas.openxmlformats.org/officeDocument/2006/relationships" xmlns:p="http://schemas.openxmlformats.org/presentationml/2006/main">
+  <p:cSld>
+    <p:spTree>
+      <p:nvGrpSpPr>
+        <p:cNvPr id="1" name=""/>
+        <p:cNvGrpSpPr/>
+        <p:nvPr/>
+      </p:nvGrpSpPr>
+      <p:grpSpPr>
+        <a:xfrm>
+          <a:off x="0" y="0"/>
+          <a:ext cx="0" cy="0"/>
+          <a:chOff x="0" y="0"/>
+          <a:chExt cx="0" cy="0"/>
+        </a:xfrm>
+      </p:grpSpPr>
+      <p:sp>
+        <p:nvSpPr>
+          <p:cNvPr id="2" name="Title 1">
+            <a:extLst>
+              <a:ext uri="{FF2B5EF4-FFF2-40B4-BE49-F238E27FC236}">
+                <a16:creationId xmlns:a16="http://schemas.microsoft.com/office/drawing/2014/main" id="{F45C7FBD-24C9-AD13-5634-7199C323CC9D}"/>
+              </a:ext>
+            </a:extLst>
+          </p:cNvPr>
+          <p:cNvSpPr>
+            <a:spLocks noGrp="1"/>
+          </p:cNvSpPr>
+          <p:nvPr>
+            <p:ph type="title"/>
+          </p:nvPr>
+        </p:nvSpPr>
+        <p:spPr/>
+        <p:txBody>
+          <a:bodyPr/>
+          <a:lstStyle/>
+          <a:p>
+            <a:r>
+              <a:rPr lang="en-US" dirty="0"/>
+              <a:t>Operational Parameters</a:t>
+            </a:r>
+          </a:p>
+        </p:txBody>
+      </p:sp>
+      <p:sp>
+        <p:nvSpPr>
+          <p:cNvPr id="3" name="Content Placeholder 2">
+            <a:extLst>
+              <a:ext uri="{FF2B5EF4-FFF2-40B4-BE49-F238E27FC236}">
+                <a16:creationId xmlns:a16="http://schemas.microsoft.com/office/drawing/2014/main" id="{E5EC9093-4C7A-9871-410D-67C230E4AF60}"/>
+              </a:ext>
+            </a:extLst>
+          </p:cNvPr>
+          <p:cNvSpPr>
+            <a:spLocks noGrp="1"/>
+          </p:cNvSpPr>
+          <p:nvPr>
+            <p:ph idx="1"/>
+          </p:nvPr>
+        </p:nvSpPr>
+        <p:spPr/>
+        <p:txBody>
+          <a:bodyPr/>
+          <a:lstStyle/>
+          <a:p>
+            <a:r>
+              <a:rPr lang="en-US" dirty="0"/>
+              <a:t>PWM frequency: 20kHz</a:t>
+            </a:r>
+          </a:p>
+          <a:p>
+            <a:r>
+              <a:rPr lang="en-US" dirty="0"/>
+              <a:t>PID Control loop: 1kHz</a:t>
+            </a:r>
+          </a:p>
+          <a:p>
+            <a:r>
+              <a:rPr lang="en-US" dirty="0"/>
+              <a:t>PD controller gains (did not spend a lot of time tuning)</a:t>
+            </a:r>
+          </a:p>
+          <a:p>
+            <a:pPr lvl="1"/>
+            <a:r>
+              <a:rPr lang="en-US" dirty="0" err="1"/>
+              <a:t>Kp</a:t>
+            </a:r>
+            <a:r>
+              <a:rPr lang="en-US" dirty="0"/>
+              <a:t> = 0.6</a:t>
+            </a:r>
+          </a:p>
+          <a:p>
+            <a:pPr lvl="1"/>
+            <a:r>
+              <a:rPr lang="en-US" dirty="0" err="1"/>
+              <a:t>Kd</a:t>
+            </a:r>
+            <a:r>
+              <a:rPr lang="en-US" dirty="0"/>
+              <a:t> = 0.025</a:t>
+            </a:r>
+          </a:p>
+          <a:p>
+            <a:r>
+              <a:rPr lang="en-US" dirty="0"/>
+              <a:t>User control input frequency: 100Hz</a:t>
+            </a:r>
+          </a:p>
+          <a:p>
+            <a:r>
+              <a:rPr lang="en-US" dirty="0"/>
+              <a:t>Data logging frequency: 10Hz</a:t>
+            </a:r>
+          </a:p>
+        </p:txBody>
+      </p:sp>
+    </p:spTree>
+    <p:extLst>
+      <p:ext uri="{BB962C8B-B14F-4D97-AF65-F5344CB8AC3E}">
+        <p14:creationId xmlns:p14="http://schemas.microsoft.com/office/powerpoint/2010/main" val="2984751551"/>
+      </p:ext>
+    </p:extLst>
+  </p:cSld>
+  <p:clrMapOvr>
+    <a:masterClrMapping/>
+  </p:clrMapOvr>
+</p:sld>
+</file>
+
+<file path=ppt/slides/slide13.xml><?xml version="1.0" encoding="utf-8"?>
+<p:sld xmlns:a="http://schemas.openxmlformats.org/drawingml/2006/main" xmlns:r="http://schemas.openxmlformats.org/officeDocument/2006/relationships" xmlns:p="http://schemas.openxmlformats.org/presentationml/2006/main">
+  <p:cSld>
+    <p:spTree>
+      <p:nvGrpSpPr>
+        <p:cNvPr id="1" name="">
+          <a:extLst>
+            <a:ext uri="{FF2B5EF4-FFF2-40B4-BE49-F238E27FC236}">
+              <a16:creationId xmlns:a16="http://schemas.microsoft.com/office/drawing/2014/main" id="{9FC50BDA-8E92-6887-98BA-6938AB3BC3F4}"/>
+            </a:ext>
+          </a:extLst>
+        </p:cNvPr>
+        <p:cNvGrpSpPr/>
+        <p:nvPr/>
+      </p:nvGrpSpPr>
+      <p:grpSpPr>
+        <a:xfrm>
+          <a:off x="0" y="0"/>
+          <a:ext cx="0" cy="0"/>
+          <a:chOff x="0" y="0"/>
+          <a:chExt cx="0" cy="0"/>
+        </a:xfrm>
+      </p:grpSpPr>
+      <p:sp>
+        <p:nvSpPr>
+          <p:cNvPr id="2" name="Title 1">
+            <a:extLst>
+              <a:ext uri="{FF2B5EF4-FFF2-40B4-BE49-F238E27FC236}">
+                <a16:creationId xmlns:a16="http://schemas.microsoft.com/office/drawing/2014/main" id="{1295D4C6-D5C7-2FEE-EF60-1E58498A13E5}"/>
+              </a:ext>
+            </a:extLst>
+          </p:cNvPr>
+          <p:cNvSpPr>
+            <a:spLocks noGrp="1"/>
+          </p:cNvSpPr>
+          <p:nvPr>
+            <p:ph type="title"/>
+          </p:nvPr>
+        </p:nvSpPr>
+        <p:spPr/>
+        <p:txBody>
+          <a:bodyPr/>
+          <a:lstStyle/>
+          <a:p>
+            <a:r>
+              <a:rPr lang="en-US" dirty="0"/>
+              <a:t>Software Overview</a:t>
+            </a:r>
+          </a:p>
+        </p:txBody>
+      </p:sp>
+      <p:sp>
+        <p:nvSpPr>
+          <p:cNvPr id="3" name="Content Placeholder 2">
+            <a:extLst>
+              <a:ext uri="{FF2B5EF4-FFF2-40B4-BE49-F238E27FC236}">
+                <a16:creationId xmlns:a16="http://schemas.microsoft.com/office/drawing/2014/main" id="{887C1B0E-9015-F493-416C-3249199401B8}"/>
+              </a:ext>
+            </a:extLst>
+          </p:cNvPr>
+          <p:cNvSpPr>
+            <a:spLocks noGrp="1"/>
+          </p:cNvSpPr>
+          <p:nvPr>
+            <p:ph idx="1"/>
+          </p:nvPr>
+        </p:nvSpPr>
+        <p:spPr/>
+        <p:txBody>
+          <a:bodyPr/>
+          <a:lstStyle/>
+          <a:p>
+            <a:r>
+              <a:rPr lang="en-US" dirty="0"/>
+              <a:t>Main Control task runs on ESP32 CORE 1 with priority 1</a:t>
+            </a:r>
+          </a:p>
+          <a:p>
+            <a:endParaRPr lang="en-US" dirty="0"/>
+          </a:p>
+          <a:p>
+            <a:r>
+              <a:rPr lang="en-US" dirty="0"/>
+              <a:t>User Input control task runs on ESP32 CORE 0 with priority 1</a:t>
+            </a:r>
+          </a:p>
+          <a:p>
+            <a:r>
+              <a:rPr lang="en-US" dirty="0"/>
+              <a:t>Data logging loop task runs on ESP32 CORE 0 with priority 2</a:t>
+            </a:r>
+          </a:p>
+          <a:p>
+            <a:endParaRPr lang="en-US" dirty="0"/>
+          </a:p>
+          <a:p>
+            <a:pPr marL="0" indent="0">
+              <a:buNone/>
+            </a:pPr>
+            <a:r>
+              <a:rPr lang="en-US" i="1" dirty="0"/>
+              <a:t>Data is shared between cores and tasks using global buffers</a:t>
+            </a:r>
+          </a:p>
+          <a:p>
+            <a:pPr marL="0" indent="0">
+              <a:buNone/>
+            </a:pPr>
+            <a:endParaRPr lang="en-US" i="1" dirty="0"/>
+          </a:p>
+          <a:p>
+            <a:pPr marL="0" indent="0">
+              <a:buNone/>
+            </a:pPr>
+            <a:r>
+              <a:rPr lang="en-US" dirty="0"/>
+              <a:t>See video overview for more in-depth information</a:t>
+            </a:r>
+          </a:p>
+        </p:txBody>
+      </p:sp>
+    </p:spTree>
+    <p:extLst>
+      <p:ext uri="{BB962C8B-B14F-4D97-AF65-F5344CB8AC3E}">
+        <p14:creationId xmlns:p14="http://schemas.microsoft.com/office/powerpoint/2010/main" val="2765721373"/>
       </p:ext>
     </p:extLst>
   </p:cSld>
@@ -3444,7 +4757,7 @@
           <a:p>
             <a:r>
               <a:rPr lang="en-US" dirty="0"/>
-              <a:t>Overview</a:t>
+              <a:t>Team</a:t>
             </a:r>
           </a:p>
         </p:txBody>
@@ -3470,7 +4783,25 @@
           <a:bodyPr/>
           <a:lstStyle/>
           <a:p>
-            <a:endParaRPr lang="en-US"/>
+            <a:pPr marL="0" indent="0">
+              <a:buNone/>
+            </a:pPr>
+            <a:r>
+              <a:rPr lang="en-US" dirty="0"/>
+              <a:t>Romeo Perlstein:</a:t>
+            </a:r>
+          </a:p>
+          <a:p>
+            <a:r>
+              <a:rPr lang="en-US" dirty="0"/>
+              <a:t>Aerospace Engineering Masters Student</a:t>
+            </a:r>
+          </a:p>
+          <a:p>
+            <a:r>
+              <a:rPr lang="en-US" dirty="0"/>
+              <a:t>Likes space robots, human spaceflight, and human/robot collaboration in space</a:t>
+            </a:r>
           </a:p>
         </p:txBody>
       </p:sp>
@@ -3492,7 +4823,13 @@
   <p:cSld>
     <p:spTree>
       <p:nvGrpSpPr>
-        <p:cNvPr id="1" name=""/>
+        <p:cNvPr id="1" name="">
+          <a:extLst>
+            <a:ext uri="{FF2B5EF4-FFF2-40B4-BE49-F238E27FC236}">
+              <a16:creationId xmlns:a16="http://schemas.microsoft.com/office/drawing/2014/main" id="{35612EC0-0C61-2A3B-8E0F-4A4A2BF1B366}"/>
+            </a:ext>
+          </a:extLst>
+        </p:cNvPr>
         <p:cNvGrpSpPr/>
         <p:nvPr/>
       </p:nvGrpSpPr>
@@ -3509,7 +4846,7 @@
           <p:cNvPr id="2" name="Title 1">
             <a:extLst>
               <a:ext uri="{FF2B5EF4-FFF2-40B4-BE49-F238E27FC236}">
-                <a16:creationId xmlns:a16="http://schemas.microsoft.com/office/drawing/2014/main" id="{C6177DF9-AED3-B923-CEE4-F9E10B407151}"/>
+                <a16:creationId xmlns:a16="http://schemas.microsoft.com/office/drawing/2014/main" id="{BE24C6C7-B24E-B63D-1400-5E56D3FD670F}"/>
               </a:ext>
             </a:extLst>
           </p:cNvPr>
@@ -3527,7 +4864,7 @@
           <a:p>
             <a:r>
               <a:rPr lang="en-US" dirty="0"/>
-              <a:t>Requirements</a:t>
+              <a:t>Project Overview</a:t>
             </a:r>
           </a:p>
         </p:txBody>
@@ -3537,7 +4874,7 @@
           <p:cNvPr id="3" name="Content Placeholder 2">
             <a:extLst>
               <a:ext uri="{FF2B5EF4-FFF2-40B4-BE49-F238E27FC236}">
-                <a16:creationId xmlns:a16="http://schemas.microsoft.com/office/drawing/2014/main" id="{AFDF77D2-222C-524D-E1C6-D8AF7898008D}"/>
+                <a16:creationId xmlns:a16="http://schemas.microsoft.com/office/drawing/2014/main" id="{E70CDCBE-B780-0CEC-8C9D-3220EB3C4878}"/>
               </a:ext>
             </a:extLst>
           </p:cNvPr>
@@ -3553,14 +4890,41 @@
           <a:bodyPr/>
           <a:lstStyle/>
           <a:p>
-            <a:endParaRPr lang="en-US"/>
+            <a:pPr marL="0" indent="0">
+              <a:buNone/>
+            </a:pPr>
+            <a:r>
+              <a:rPr lang="en-US" b="1" u="sng" dirty="0"/>
+              <a:t>Mission Statement:</a:t>
+            </a:r>
+          </a:p>
+          <a:p>
+            <a:pPr marL="0" indent="0">
+              <a:buNone/>
+            </a:pPr>
+            <a:r>
+              <a:rPr lang="en-US" dirty="0"/>
+              <a:t>Control the position of a hobby-grade brushless DC motor</a:t>
+            </a:r>
+          </a:p>
+          <a:p>
+            <a:pPr marL="0" indent="0">
+              <a:buNone/>
+            </a:pPr>
+            <a:endParaRPr lang="en-US" dirty="0"/>
+          </a:p>
+          <a:p>
+            <a:pPr marL="0" indent="0">
+              <a:buNone/>
+            </a:pPr>
+            <a:endParaRPr lang="en-US" dirty="0"/>
           </a:p>
         </p:txBody>
       </p:sp>
     </p:spTree>
     <p:extLst>
       <p:ext uri="{BB962C8B-B14F-4D97-AF65-F5344CB8AC3E}">
-        <p14:creationId xmlns:p14="http://schemas.microsoft.com/office/powerpoint/2010/main" val="1209623022"/>
+        <p14:creationId xmlns:p14="http://schemas.microsoft.com/office/powerpoint/2010/main" val="280174077"/>
       </p:ext>
     </p:extLst>
   </p:cSld>
@@ -3592,7 +4956,7 @@
           <p:cNvPr id="2" name="Title 1">
             <a:extLst>
               <a:ext uri="{FF2B5EF4-FFF2-40B4-BE49-F238E27FC236}">
-                <a16:creationId xmlns:a16="http://schemas.microsoft.com/office/drawing/2014/main" id="{38A5C4F5-8582-133D-4862-EA39B80ADEAF}"/>
+                <a16:creationId xmlns:a16="http://schemas.microsoft.com/office/drawing/2014/main" id="{C6177DF9-AED3-B923-CEE4-F9E10B407151}"/>
               </a:ext>
             </a:extLst>
           </p:cNvPr>
@@ -3610,7 +4974,7 @@
           <a:p>
             <a:r>
               <a:rPr lang="en-US" dirty="0"/>
-              <a:t>Components</a:t>
+              <a:t>Requirements</a:t>
             </a:r>
           </a:p>
         </p:txBody>
@@ -3620,7 +4984,7 @@
           <p:cNvPr id="3" name="Content Placeholder 2">
             <a:extLst>
               <a:ext uri="{FF2B5EF4-FFF2-40B4-BE49-F238E27FC236}">
-                <a16:creationId xmlns:a16="http://schemas.microsoft.com/office/drawing/2014/main" id="{49CE2960-59CD-DF9C-733E-C6EF63E86DDC}"/>
+                <a16:creationId xmlns:a16="http://schemas.microsoft.com/office/drawing/2014/main" id="{AFDF77D2-222C-524D-E1C6-D8AF7898008D}"/>
               </a:ext>
             </a:extLst>
           </p:cNvPr>
@@ -3636,14 +5000,56 @@
           <a:bodyPr/>
           <a:lstStyle/>
           <a:p>
-            <a:endParaRPr lang="en-US"/>
+            <a:pPr marL="0" indent="0">
+              <a:buNone/>
+            </a:pPr>
+            <a:r>
+              <a:rPr lang="en-US" b="1" u="sng" dirty="0"/>
+              <a:t>Mission Level Requirements:</a:t>
+            </a:r>
+          </a:p>
+          <a:p>
+            <a:pPr marL="514350" indent="-514350">
+              <a:buAutoNum type="arabicPeriod"/>
+            </a:pPr>
+            <a:r>
+              <a:rPr lang="en-US" dirty="0"/>
+              <a:t>Fast control loop to implement basic PD controller</a:t>
+            </a:r>
+          </a:p>
+          <a:p>
+            <a:pPr marL="514350" indent="-514350">
+              <a:buAutoNum type="arabicPeriod"/>
+            </a:pPr>
+            <a:r>
+              <a:rPr lang="en-US" dirty="0"/>
+              <a:t>Position encoder to track live position of motor</a:t>
+            </a:r>
+          </a:p>
+          <a:p>
+            <a:pPr marL="514350" indent="-514350">
+              <a:buAutoNum type="arabicPeriod"/>
+            </a:pPr>
+            <a:r>
+              <a:rPr lang="en-US" dirty="0"/>
+              <a:t>Brushless DC motor</a:t>
+            </a:r>
+          </a:p>
+          <a:p>
+            <a:pPr marL="514350" indent="-514350">
+              <a:buAutoNum type="arabicPeriod"/>
+            </a:pPr>
+            <a:r>
+              <a:rPr lang="en-US" dirty="0"/>
+              <a:t>Brushless DC motor driver</a:t>
+            </a:r>
           </a:p>
         </p:txBody>
       </p:sp>
     </p:spTree>
     <p:extLst>
       <p:ext uri="{BB962C8B-B14F-4D97-AF65-F5344CB8AC3E}">
-        <p14:creationId xmlns:p14="http://schemas.microsoft.com/office/powerpoint/2010/main" val="1566628785"/>
+        <p14:creationId xmlns:p14="http://schemas.microsoft.com/office/powerpoint/2010/main" val="1209623022"/>
       </p:ext>
     </p:extLst>
   </p:cSld>
@@ -3658,7 +5064,13 @@
   <p:cSld>
     <p:spTree>
       <p:nvGrpSpPr>
-        <p:cNvPr id="1" name=""/>
+        <p:cNvPr id="1" name="">
+          <a:extLst>
+            <a:ext uri="{FF2B5EF4-FFF2-40B4-BE49-F238E27FC236}">
+              <a16:creationId xmlns:a16="http://schemas.microsoft.com/office/drawing/2014/main" id="{19EAB8B7-D19D-84C9-4884-6663B82AA41F}"/>
+            </a:ext>
+          </a:extLst>
+        </p:cNvPr>
         <p:cNvGrpSpPr/>
         <p:nvPr/>
       </p:nvGrpSpPr>
@@ -3675,7 +5087,7 @@
           <p:cNvPr id="2" name="Title 1">
             <a:extLst>
               <a:ext uri="{FF2B5EF4-FFF2-40B4-BE49-F238E27FC236}">
-                <a16:creationId xmlns:a16="http://schemas.microsoft.com/office/drawing/2014/main" id="{B2D51D0E-C832-C317-197C-1F1DC2963CB2}"/>
+                <a16:creationId xmlns:a16="http://schemas.microsoft.com/office/drawing/2014/main" id="{106BAFA3-23C5-8B6C-C67D-F66833A668DF}"/>
               </a:ext>
             </a:extLst>
           </p:cNvPr>
@@ -3693,7 +5105,7 @@
           <a:p>
             <a:r>
               <a:rPr lang="en-US" dirty="0"/>
-              <a:t>Wiring Diagram</a:t>
+              <a:t>Requirements</a:t>
             </a:r>
           </a:p>
         </p:txBody>
@@ -3703,7 +5115,7 @@
           <p:cNvPr id="3" name="Content Placeholder 2">
             <a:extLst>
               <a:ext uri="{FF2B5EF4-FFF2-40B4-BE49-F238E27FC236}">
-                <a16:creationId xmlns:a16="http://schemas.microsoft.com/office/drawing/2014/main" id="{BA0198A7-815B-D7D3-8D33-447B2CC737CF}"/>
+                <a16:creationId xmlns:a16="http://schemas.microsoft.com/office/drawing/2014/main" id="{A5E72163-C52C-DC3F-47DF-28B9E52DAB25}"/>
               </a:ext>
             </a:extLst>
           </p:cNvPr>
@@ -3716,17 +5128,61 @@
         </p:nvSpPr>
         <p:spPr/>
         <p:txBody>
-          <a:bodyPr/>
-          <a:lstStyle/>
-          <a:p>
-            <a:endParaRPr lang="en-US"/>
+          <a:bodyPr>
+            <a:normAutofit lnSpcReduction="10000"/>
+          </a:bodyPr>
+          <a:lstStyle/>
+          <a:p>
+            <a:pPr marL="0" indent="0">
+              <a:buNone/>
+            </a:pPr>
+            <a:r>
+              <a:rPr lang="en-US" b="1" u="sng" dirty="0"/>
+              <a:t>Mission Level Requirements Reasonings:</a:t>
+            </a:r>
+          </a:p>
+          <a:p>
+            <a:pPr marL="514350" indent="-514350">
+              <a:buAutoNum type="arabicPeriod"/>
+            </a:pPr>
+            <a:r>
+              <a:rPr lang="en-US" dirty="0"/>
+              <a:t>PD controller needs to run at a relatively fast rate for good tracking</a:t>
+            </a:r>
+          </a:p>
+          <a:p>
+            <a:pPr marL="514350" indent="-514350">
+              <a:buAutoNum type="arabicPeriod"/>
+            </a:pPr>
+            <a:r>
+              <a:rPr lang="en-US" dirty="0"/>
+              <a:t>Need positional sensor readings in order to command position using PD controller</a:t>
+            </a:r>
+          </a:p>
+          <a:p>
+            <a:pPr marL="514350" indent="-514350">
+              <a:buAutoNum type="arabicPeriod"/>
+            </a:pPr>
+            <a:r>
+              <a:rPr lang="en-US" dirty="0"/>
+              <a:t>Need physical actuator to drive system, brushless DC motors are relatively challenging to work with compared to brushed DC motors and enable a more challenging project</a:t>
+            </a:r>
+          </a:p>
+          <a:p>
+            <a:pPr marL="514350" indent="-514350">
+              <a:buAutoNum type="arabicPeriod"/>
+            </a:pPr>
+            <a:r>
+              <a:rPr lang="en-US" dirty="0"/>
+              <a:t>Need a drive to convert command signals to phase current cycles (developing a custom one deemed out-of-scope)</a:t>
+            </a:r>
           </a:p>
         </p:txBody>
       </p:sp>
     </p:spTree>
     <p:extLst>
       <p:ext uri="{BB962C8B-B14F-4D97-AF65-F5344CB8AC3E}">
-        <p14:creationId xmlns:p14="http://schemas.microsoft.com/office/powerpoint/2010/main" val="2795728212"/>
+        <p14:creationId xmlns:p14="http://schemas.microsoft.com/office/powerpoint/2010/main" val="1505833946"/>
       </p:ext>
     </p:extLst>
   </p:cSld>
@@ -3741,7 +5197,13 @@
   <p:cSld>
     <p:spTree>
       <p:nvGrpSpPr>
-        <p:cNvPr id="1" name=""/>
+        <p:cNvPr id="1" name="">
+          <a:extLst>
+            <a:ext uri="{FF2B5EF4-FFF2-40B4-BE49-F238E27FC236}">
+              <a16:creationId xmlns:a16="http://schemas.microsoft.com/office/drawing/2014/main" id="{1BEA7CDA-3C34-56C1-1215-6E470E91AE79}"/>
+            </a:ext>
+          </a:extLst>
+        </p:cNvPr>
         <p:cNvGrpSpPr/>
         <p:nvPr/>
       </p:nvGrpSpPr>
@@ -3758,7 +5220,7 @@
           <p:cNvPr id="2" name="Title 1">
             <a:extLst>
               <a:ext uri="{FF2B5EF4-FFF2-40B4-BE49-F238E27FC236}">
-                <a16:creationId xmlns:a16="http://schemas.microsoft.com/office/drawing/2014/main" id="{F45C7FBD-24C9-AD13-5634-7199C323CC9D}"/>
+                <a16:creationId xmlns:a16="http://schemas.microsoft.com/office/drawing/2014/main" id="{C0D34F06-3C72-0DD2-71D7-DC2044957911}"/>
               </a:ext>
             </a:extLst>
           </p:cNvPr>
@@ -3776,7 +5238,7 @@
           <a:p>
             <a:r>
               <a:rPr lang="en-US" dirty="0"/>
-              <a:t>Operational Parameters</a:t>
+              <a:t>Requirements Cont’d</a:t>
             </a:r>
           </a:p>
         </p:txBody>
@@ -3786,7 +5248,7 @@
           <p:cNvPr id="3" name="Content Placeholder 2">
             <a:extLst>
               <a:ext uri="{FF2B5EF4-FFF2-40B4-BE49-F238E27FC236}">
-                <a16:creationId xmlns:a16="http://schemas.microsoft.com/office/drawing/2014/main" id="{E5EC9093-4C7A-9871-410D-67C230E4AF60}"/>
+                <a16:creationId xmlns:a16="http://schemas.microsoft.com/office/drawing/2014/main" id="{297460C4-99F3-2A37-BB65-BF45D19A796D}"/>
               </a:ext>
             </a:extLst>
           </p:cNvPr>
@@ -3802,15 +5264,70 @@
           <a:bodyPr/>
           <a:lstStyle/>
           <a:p>
+            <a:pPr marL="0" indent="0">
+              <a:buNone/>
+            </a:pPr>
+            <a:r>
+              <a:rPr lang="en-US" b="1" u="sng" dirty="0"/>
+              <a:t>System Level Requirements:</a:t>
+            </a:r>
+          </a:p>
+          <a:p>
+            <a:pPr marL="514350" indent="-514350">
+              <a:buFont typeface="+mj-lt"/>
+              <a:buAutoNum type="arabicPeriod"/>
+            </a:pPr>
             <a:r>
               <a:rPr lang="en-US" dirty="0"/>
-              <a:t>PWM frequency: 20kHz !</a:t>
-            </a:r>
-          </a:p>
-          <a:p>
+              <a:t>Control loop that can run on the order of ~1kHz</a:t>
+            </a:r>
+          </a:p>
+          <a:p>
+            <a:pPr marL="514350" indent="-514350">
+              <a:buFont typeface="+mj-lt"/>
+              <a:buAutoNum type="arabicPeriod"/>
+            </a:pPr>
             <a:r>
               <a:rPr lang="en-US" dirty="0"/>
-              <a:t>PID Control loop: 1kHz</a:t>
+              <a:t>Ability to read encoder pulses at frequency of ~10kHz</a:t>
+            </a:r>
+          </a:p>
+          <a:p>
+            <a:pPr marL="514350" indent="-514350">
+              <a:buFont typeface="+mj-lt"/>
+              <a:buAutoNum type="arabicPeriod"/>
+            </a:pPr>
+            <a:r>
+              <a:rPr lang="en-US" dirty="0"/>
+              <a:t>Ability to generate pulse-width-modulated (PWM) signal at frequency of roughly ~20kHz</a:t>
+            </a:r>
+          </a:p>
+          <a:p>
+            <a:pPr marL="514350" indent="-514350">
+              <a:buFont typeface="+mj-lt"/>
+              <a:buAutoNum type="arabicPeriod"/>
+            </a:pPr>
+            <a:r>
+              <a:rPr lang="en-US" dirty="0"/>
+              <a:t>Ability to send digital outputs at a fast rate (~1kHz)</a:t>
+            </a:r>
+          </a:p>
+          <a:p>
+            <a:pPr marL="514350" indent="-514350">
+              <a:buFont typeface="+mj-lt"/>
+              <a:buAutoNum type="arabicPeriod"/>
+            </a:pPr>
+            <a:r>
+              <a:rPr lang="en-US" dirty="0"/>
+              <a:t>Control input circuit (</a:t>
+            </a:r>
+            <a:r>
+              <a:rPr lang="en-US" dirty="0" err="1"/>
+              <a:t>a.k.a</a:t>
+            </a:r>
+            <a:r>
+              <a:rPr lang="en-US" dirty="0"/>
+              <a:t> potentiometer) for position commands</a:t>
             </a:r>
           </a:p>
         </p:txBody>
@@ -3818,7 +5335,342 @@
     </p:spTree>
     <p:extLst>
       <p:ext uri="{BB962C8B-B14F-4D97-AF65-F5344CB8AC3E}">
-        <p14:creationId xmlns:p14="http://schemas.microsoft.com/office/powerpoint/2010/main" val="2984751551"/>
+        <p14:creationId xmlns:p14="http://schemas.microsoft.com/office/powerpoint/2010/main" val="47073881"/>
+      </p:ext>
+    </p:extLst>
+  </p:cSld>
+  <p:clrMapOvr>
+    <a:masterClrMapping/>
+  </p:clrMapOvr>
+</p:sld>
+</file>
+
+<file path=ppt/slides/slide7.xml><?xml version="1.0" encoding="utf-8"?>
+<p:sld xmlns:a="http://schemas.openxmlformats.org/drawingml/2006/main" xmlns:r="http://schemas.openxmlformats.org/officeDocument/2006/relationships" xmlns:p="http://schemas.openxmlformats.org/presentationml/2006/main">
+  <p:cSld>
+    <p:spTree>
+      <p:nvGrpSpPr>
+        <p:cNvPr id="1" name="">
+          <a:extLst>
+            <a:ext uri="{FF2B5EF4-FFF2-40B4-BE49-F238E27FC236}">
+              <a16:creationId xmlns:a16="http://schemas.microsoft.com/office/drawing/2014/main" id="{4ADEA3B6-645D-BDD2-EE23-E30FA1B81541}"/>
+            </a:ext>
+          </a:extLst>
+        </p:cNvPr>
+        <p:cNvGrpSpPr/>
+        <p:nvPr/>
+      </p:nvGrpSpPr>
+      <p:grpSpPr>
+        <a:xfrm>
+          <a:off x="0" y="0"/>
+          <a:ext cx="0" cy="0"/>
+          <a:chOff x="0" y="0"/>
+          <a:chExt cx="0" cy="0"/>
+        </a:xfrm>
+      </p:grpSpPr>
+      <p:sp>
+        <p:nvSpPr>
+          <p:cNvPr id="2" name="Title 1">
+            <a:extLst>
+              <a:ext uri="{FF2B5EF4-FFF2-40B4-BE49-F238E27FC236}">
+                <a16:creationId xmlns:a16="http://schemas.microsoft.com/office/drawing/2014/main" id="{7A1ECEC6-3945-979A-C88F-A8377BD3E3C4}"/>
+              </a:ext>
+            </a:extLst>
+          </p:cNvPr>
+          <p:cNvSpPr>
+            <a:spLocks noGrp="1"/>
+          </p:cNvSpPr>
+          <p:nvPr>
+            <p:ph type="title"/>
+          </p:nvPr>
+        </p:nvSpPr>
+        <p:spPr/>
+        <p:txBody>
+          <a:bodyPr/>
+          <a:lstStyle/>
+          <a:p>
+            <a:r>
+              <a:rPr lang="en-US" dirty="0"/>
+              <a:t>Requirements Cont’d</a:t>
+            </a:r>
+          </a:p>
+        </p:txBody>
+      </p:sp>
+      <p:sp>
+        <p:nvSpPr>
+          <p:cNvPr id="3" name="Content Placeholder 2">
+            <a:extLst>
+              <a:ext uri="{FF2B5EF4-FFF2-40B4-BE49-F238E27FC236}">
+                <a16:creationId xmlns:a16="http://schemas.microsoft.com/office/drawing/2014/main" id="{D15C3764-401B-3431-20A3-C3FA427830F1}"/>
+              </a:ext>
+            </a:extLst>
+          </p:cNvPr>
+          <p:cNvSpPr>
+            <a:spLocks noGrp="1"/>
+          </p:cNvSpPr>
+          <p:nvPr>
+            <p:ph idx="1"/>
+          </p:nvPr>
+        </p:nvSpPr>
+        <p:spPr/>
+        <p:txBody>
+          <a:bodyPr>
+            <a:normAutofit/>
+          </a:bodyPr>
+          <a:lstStyle/>
+          <a:p>
+            <a:pPr marL="0" indent="0">
+              <a:buNone/>
+            </a:pPr>
+            <a:r>
+              <a:rPr lang="en-US" b="1" u="sng" dirty="0"/>
+              <a:t>System Level Requirements Reasoning:</a:t>
+            </a:r>
+          </a:p>
+          <a:p>
+            <a:pPr marL="514350" indent="-514350">
+              <a:buFont typeface="+mj-lt"/>
+              <a:buAutoNum type="arabicPeriod"/>
+            </a:pPr>
+            <a:r>
+              <a:rPr lang="en-US" dirty="0"/>
+              <a:t>Position PID control of motors needs to run at frequencies on the order of kHz or faster for stable and smooth control</a:t>
+            </a:r>
+          </a:p>
+          <a:p>
+            <a:pPr marL="514350" indent="-514350">
+              <a:buFont typeface="+mj-lt"/>
+              <a:buAutoNum type="arabicPeriod"/>
+            </a:pPr>
+            <a:r>
+              <a:rPr lang="en-US" dirty="0"/>
+              <a:t>High-resolution encoders generate pulses faster than typical while loops or interrupt service routines can handle</a:t>
+            </a:r>
+          </a:p>
+          <a:p>
+            <a:pPr marL="514350" indent="-514350">
+              <a:buFont typeface="+mj-lt"/>
+              <a:buAutoNum type="arabicPeriod"/>
+            </a:pPr>
+            <a:r>
+              <a:rPr lang="en-US" dirty="0"/>
+              <a:t>High frequency PWM signals enable smooth motor motion</a:t>
+            </a:r>
+          </a:p>
+          <a:p>
+            <a:pPr marL="514350" indent="-514350">
+              <a:buFont typeface="+mj-lt"/>
+              <a:buAutoNum type="arabicPeriod"/>
+            </a:pPr>
+            <a:r>
+              <a:rPr lang="en-US" dirty="0"/>
+              <a:t>Digital output for direction has to change at the same rate of the control loop</a:t>
+            </a:r>
+          </a:p>
+          <a:p>
+            <a:pPr marL="514350" indent="-514350">
+              <a:buFont typeface="+mj-lt"/>
+              <a:buAutoNum type="arabicPeriod"/>
+            </a:pPr>
+            <a:r>
+              <a:rPr lang="en-US" dirty="0"/>
+              <a:t>User input to demonstrate motor control</a:t>
+            </a:r>
+          </a:p>
+        </p:txBody>
+      </p:sp>
+    </p:spTree>
+    <p:extLst>
+      <p:ext uri="{BB962C8B-B14F-4D97-AF65-F5344CB8AC3E}">
+        <p14:creationId xmlns:p14="http://schemas.microsoft.com/office/powerpoint/2010/main" val="2495590335"/>
+      </p:ext>
+    </p:extLst>
+  </p:cSld>
+  <p:clrMapOvr>
+    <a:masterClrMapping/>
+  </p:clrMapOvr>
+</p:sld>
+</file>
+
+<file path=ppt/slides/slide8.xml><?xml version="1.0" encoding="utf-8"?>
+<p:sld xmlns:a="http://schemas.openxmlformats.org/drawingml/2006/main" xmlns:r="http://schemas.openxmlformats.org/officeDocument/2006/relationships" xmlns:p="http://schemas.openxmlformats.org/presentationml/2006/main">
+  <p:cSld>
+    <p:spTree>
+      <p:nvGrpSpPr>
+        <p:cNvPr id="1" name="">
+          <a:extLst>
+            <a:ext uri="{FF2B5EF4-FFF2-40B4-BE49-F238E27FC236}">
+              <a16:creationId xmlns:a16="http://schemas.microsoft.com/office/drawing/2014/main" id="{53009E44-CEEF-9FCB-25E3-41966D216BDC}"/>
+            </a:ext>
+          </a:extLst>
+        </p:cNvPr>
+        <p:cNvGrpSpPr/>
+        <p:nvPr/>
+      </p:nvGrpSpPr>
+      <p:grpSpPr>
+        <a:xfrm>
+          <a:off x="0" y="0"/>
+          <a:ext cx="0" cy="0"/>
+          <a:chOff x="0" y="0"/>
+          <a:chExt cx="0" cy="0"/>
+        </a:xfrm>
+      </p:grpSpPr>
+      <p:sp>
+        <p:nvSpPr>
+          <p:cNvPr id="2" name="Title 1">
+            <a:extLst>
+              <a:ext uri="{FF2B5EF4-FFF2-40B4-BE49-F238E27FC236}">
+                <a16:creationId xmlns:a16="http://schemas.microsoft.com/office/drawing/2014/main" id="{6824AEA1-277B-4AC1-4C0E-E9198E57BD86}"/>
+              </a:ext>
+            </a:extLst>
+          </p:cNvPr>
+          <p:cNvSpPr>
+            <a:spLocks noGrp="1"/>
+          </p:cNvSpPr>
+          <p:nvPr>
+            <p:ph type="title"/>
+          </p:nvPr>
+        </p:nvSpPr>
+        <p:spPr/>
+        <p:txBody>
+          <a:bodyPr/>
+          <a:lstStyle/>
+          <a:p>
+            <a:r>
+              <a:rPr lang="en-US" dirty="0"/>
+              <a:t>Final System</a:t>
+            </a:r>
+          </a:p>
+        </p:txBody>
+      </p:sp>
+      <p:sp>
+        <p:nvSpPr>
+          <p:cNvPr id="3" name="Content Placeholder 2">
+            <a:extLst>
+              <a:ext uri="{FF2B5EF4-FFF2-40B4-BE49-F238E27FC236}">
+                <a16:creationId xmlns:a16="http://schemas.microsoft.com/office/drawing/2014/main" id="{DD73C692-B5D0-07D2-88A6-666C7BC37148}"/>
+              </a:ext>
+            </a:extLst>
+          </p:cNvPr>
+          <p:cNvSpPr>
+            <a:spLocks noGrp="1"/>
+          </p:cNvSpPr>
+          <p:nvPr>
+            <p:ph idx="1"/>
+          </p:nvPr>
+        </p:nvSpPr>
+        <p:spPr/>
+        <p:txBody>
+          <a:bodyPr>
+            <a:normAutofit/>
+          </a:bodyPr>
+          <a:lstStyle/>
+          <a:p>
+            <a:pPr marL="0" indent="0">
+              <a:buNone/>
+            </a:pPr>
+            <a:endParaRPr lang="en-US" dirty="0"/>
+          </a:p>
+        </p:txBody>
+      </p:sp>
+    </p:spTree>
+    <p:extLst>
+      <p:ext uri="{BB962C8B-B14F-4D97-AF65-F5344CB8AC3E}">
+        <p14:creationId xmlns:p14="http://schemas.microsoft.com/office/powerpoint/2010/main" val="878335247"/>
+      </p:ext>
+    </p:extLst>
+  </p:cSld>
+  <p:clrMapOvr>
+    <a:masterClrMapping/>
+  </p:clrMapOvr>
+</p:sld>
+</file>
+
+<file path=ppt/slides/slide9.xml><?xml version="1.0" encoding="utf-8"?>
+<p:sld xmlns:a="http://schemas.openxmlformats.org/drawingml/2006/main" xmlns:r="http://schemas.openxmlformats.org/officeDocument/2006/relationships" xmlns:p="http://schemas.openxmlformats.org/presentationml/2006/main">
+  <p:cSld>
+    <p:spTree>
+      <p:nvGrpSpPr>
+        <p:cNvPr id="1" name="">
+          <a:extLst>
+            <a:ext uri="{FF2B5EF4-FFF2-40B4-BE49-F238E27FC236}">
+              <a16:creationId xmlns:a16="http://schemas.microsoft.com/office/drawing/2014/main" id="{55C9B53D-19DC-B5CC-9F36-0E51BC98F1E6}"/>
+            </a:ext>
+          </a:extLst>
+        </p:cNvPr>
+        <p:cNvGrpSpPr/>
+        <p:nvPr/>
+      </p:nvGrpSpPr>
+      <p:grpSpPr>
+        <a:xfrm>
+          <a:off x="0" y="0"/>
+          <a:ext cx="0" cy="0"/>
+          <a:chOff x="0" y="0"/>
+          <a:chExt cx="0" cy="0"/>
+        </a:xfrm>
+      </p:grpSpPr>
+      <p:sp>
+        <p:nvSpPr>
+          <p:cNvPr id="2" name="Title 1">
+            <a:extLst>
+              <a:ext uri="{FF2B5EF4-FFF2-40B4-BE49-F238E27FC236}">
+                <a16:creationId xmlns:a16="http://schemas.microsoft.com/office/drawing/2014/main" id="{4097E17D-50DF-ACAF-31A8-C0B300C916BE}"/>
+              </a:ext>
+            </a:extLst>
+          </p:cNvPr>
+          <p:cNvSpPr>
+            <a:spLocks noGrp="1"/>
+          </p:cNvSpPr>
+          <p:nvPr>
+            <p:ph type="title"/>
+          </p:nvPr>
+        </p:nvSpPr>
+        <p:spPr/>
+        <p:txBody>
+          <a:bodyPr/>
+          <a:lstStyle/>
+          <a:p>
+            <a:r>
+              <a:rPr lang="en-US" dirty="0"/>
+              <a:t>Final System (labeled)</a:t>
+            </a:r>
+          </a:p>
+        </p:txBody>
+      </p:sp>
+      <p:sp>
+        <p:nvSpPr>
+          <p:cNvPr id="3" name="Content Placeholder 2">
+            <a:extLst>
+              <a:ext uri="{FF2B5EF4-FFF2-40B4-BE49-F238E27FC236}">
+                <a16:creationId xmlns:a16="http://schemas.microsoft.com/office/drawing/2014/main" id="{BD6251D1-9EE4-2158-8E50-C3DB2FA4EEAC}"/>
+              </a:ext>
+            </a:extLst>
+          </p:cNvPr>
+          <p:cNvSpPr>
+            <a:spLocks noGrp="1"/>
+          </p:cNvSpPr>
+          <p:nvPr>
+            <p:ph idx="1"/>
+          </p:nvPr>
+        </p:nvSpPr>
+        <p:spPr/>
+        <p:txBody>
+          <a:bodyPr>
+            <a:normAutofit/>
+          </a:bodyPr>
+          <a:lstStyle/>
+          <a:p>
+            <a:pPr marL="0" indent="0">
+              <a:buNone/>
+            </a:pPr>
+            <a:endParaRPr lang="en-US" dirty="0"/>
+          </a:p>
+        </p:txBody>
+      </p:sp>
+    </p:spTree>
+    <p:extLst>
+      <p:ext uri="{BB962C8B-B14F-4D97-AF65-F5344CB8AC3E}">
+        <p14:creationId xmlns:p14="http://schemas.microsoft.com/office/powerpoint/2010/main" val="3380868050"/>
       </p:ext>
     </p:extLst>
   </p:cSld>
@@ -4141,4 +5993,319 @@
     </a:ext>
   </a:extLst>
 </a:theme>
+</file>
+
+<file path=ppt/theme/theme2.xml><?xml version="1.0" encoding="utf-8"?>
+<a:theme xmlns:a="http://schemas.openxmlformats.org/drawingml/2006/main" name="Office Theme">
+  <a:themeElements>
+    <a:clrScheme name="Office">
+      <a:dk1>
+        <a:sysClr val="windowText" lastClr="000000"/>
+      </a:dk1>
+      <a:lt1>
+        <a:sysClr val="window" lastClr="FFFFFF"/>
+      </a:lt1>
+      <a:dk2>
+        <a:srgbClr val="0E2841"/>
+      </a:dk2>
+      <a:lt2>
+        <a:srgbClr val="E8E8E8"/>
+      </a:lt2>
+      <a:accent1>
+        <a:srgbClr val="156082"/>
+      </a:accent1>
+      <a:accent2>
+        <a:srgbClr val="E97132"/>
+      </a:accent2>
+      <a:accent3>
+        <a:srgbClr val="196B24"/>
+      </a:accent3>
+      <a:accent4>
+        <a:srgbClr val="0F9ED5"/>
+      </a:accent4>
+      <a:accent5>
+        <a:srgbClr val="A02B93"/>
+      </a:accent5>
+      <a:accent6>
+        <a:srgbClr val="4EA72E"/>
+      </a:accent6>
+      <a:hlink>
+        <a:srgbClr val="467886"/>
+      </a:hlink>
+      <a:folHlink>
+        <a:srgbClr val="96607D"/>
+      </a:folHlink>
+    </a:clrScheme>
+    <a:fontScheme name="Office">
+      <a:majorFont>
+        <a:latin typeface="Aptos Display" panose="02110004020202020204"/>
+        <a:ea typeface=""/>
+        <a:cs typeface=""/>
+        <a:font script="Jpan" typeface="游ゴシック Light"/>
+        <a:font script="Hang" typeface="맑은 고딕"/>
+        <a:font script="Hans" typeface="等线 Light"/>
+        <a:font script="Hant" typeface="新細明體"/>
+        <a:font script="Arab" typeface="Times New Roman"/>
+        <a:font script="Hebr" typeface="Times New Roman"/>
+        <a:font script="Thai" typeface="Angsana New"/>
+        <a:font script="Ethi" typeface="Nyala"/>
+        <a:font script="Beng" typeface="Vrinda"/>
+        <a:font script="Gujr" typeface="Shruti"/>
+        <a:font script="Khmr" typeface="MoolBoran"/>
+        <a:font script="Knda" typeface="Tunga"/>
+        <a:font script="Guru" typeface="Raavi"/>
+        <a:font script="Cans" typeface="Euphemia"/>
+        <a:font script="Cher" typeface="Plantagenet Cherokee"/>
+        <a:font script="Yiii" typeface="Microsoft Yi Baiti"/>
+        <a:font script="Tibt" typeface="Microsoft Himalaya"/>
+        <a:font script="Thaa" typeface="MV Boli"/>
+        <a:font script="Deva" typeface="Mangal"/>
+        <a:font script="Telu" typeface="Gautami"/>
+        <a:font script="Taml" typeface="Latha"/>
+        <a:font script="Syrc" typeface="Estrangelo Edessa"/>
+        <a:font script="Orya" typeface="Kalinga"/>
+        <a:font script="Mlym" typeface="Kartika"/>
+        <a:font script="Laoo" typeface="DokChampa"/>
+        <a:font script="Sinh" typeface="Iskoola Pota"/>
+        <a:font script="Mong" typeface="Mongolian Baiti"/>
+        <a:font script="Viet" typeface="Times New Roman"/>
+        <a:font script="Uigh" typeface="Microsoft Uighur"/>
+        <a:font script="Geor" typeface="Sylfaen"/>
+        <a:font script="Armn" typeface="Arial"/>
+        <a:font script="Bugi" typeface="Leelawadee UI"/>
+        <a:font script="Bopo" typeface="Microsoft JhengHei"/>
+        <a:font script="Java" typeface="Javanese Text"/>
+        <a:font script="Lisu" typeface="Segoe UI"/>
+        <a:font script="Mymr" typeface="Myanmar Text"/>
+        <a:font script="Nkoo" typeface="Ebrima"/>
+        <a:font script="Olck" typeface="Nirmala UI"/>
+        <a:font script="Osma" typeface="Ebrima"/>
+        <a:font script="Phag" typeface="Phagspa"/>
+        <a:font script="Syrn" typeface="Estrangelo Edessa"/>
+        <a:font script="Syrj" typeface="Estrangelo Edessa"/>
+        <a:font script="Syre" typeface="Estrangelo Edessa"/>
+        <a:font script="Sora" typeface="Nirmala UI"/>
+        <a:font script="Tale" typeface="Microsoft Tai Le"/>
+        <a:font script="Talu" typeface="Microsoft New Tai Lue"/>
+        <a:font script="Tfng" typeface="Ebrima"/>
+      </a:majorFont>
+      <a:minorFont>
+        <a:latin typeface="Aptos" panose="02110004020202020204"/>
+        <a:ea typeface=""/>
+        <a:cs typeface=""/>
+        <a:font script="Jpan" typeface="游ゴシック"/>
+        <a:font script="Hang" typeface="맑은 고딕"/>
+        <a:font script="Hans" typeface="等线"/>
+        <a:font script="Hant" typeface="新細明體"/>
+        <a:font script="Arab" typeface="Arial"/>
+        <a:font script="Hebr" typeface="Arial"/>
+        <a:font script="Thai" typeface="Cordia New"/>
+        <a:font script="Ethi" typeface="Nyala"/>
+        <a:font script="Beng" typeface="Vrinda"/>
+        <a:font script="Gujr" typeface="Shruti"/>
+        <a:font script="Khmr" typeface="DaunPenh"/>
+        <a:font script="Knda" typeface="Tunga"/>
+        <a:font script="Guru" typeface="Raavi"/>
+        <a:font script="Cans" typeface="Euphemia"/>
+        <a:font script="Cher" typeface="Plantagenet Cherokee"/>
+        <a:font script="Yiii" typeface="Microsoft Yi Baiti"/>
+        <a:font script="Tibt" typeface="Microsoft Himalaya"/>
+        <a:font script="Thaa" typeface="MV Boli"/>
+        <a:font script="Deva" typeface="Mangal"/>
+        <a:font script="Telu" typeface="Gautami"/>
+        <a:font script="Taml" typeface="Latha"/>
+        <a:font script="Syrc" typeface="Estrangelo Edessa"/>
+        <a:font script="Orya" typeface="Kalinga"/>
+        <a:font script="Mlym" typeface="Kartika"/>
+        <a:font script="Laoo" typeface="DokChampa"/>
+        <a:font script="Sinh" typeface="Iskoola Pota"/>
+        <a:font script="Mong" typeface="Mongolian Baiti"/>
+        <a:font script="Viet" typeface="Arial"/>
+        <a:font script="Uigh" typeface="Microsoft Uighur"/>
+        <a:font script="Geor" typeface="Sylfaen"/>
+        <a:font script="Armn" typeface="Arial"/>
+        <a:font script="Bugi" typeface="Leelawadee UI"/>
+        <a:font script="Bopo" typeface="Microsoft JhengHei"/>
+        <a:font script="Java" typeface="Javanese Text"/>
+        <a:font script="Lisu" typeface="Segoe UI"/>
+        <a:font script="Mymr" typeface="Myanmar Text"/>
+        <a:font script="Nkoo" typeface="Ebrima"/>
+        <a:font script="Olck" typeface="Nirmala UI"/>
+        <a:font script="Osma" typeface="Ebrima"/>
+        <a:font script="Phag" typeface="Phagspa"/>
+        <a:font script="Syrn" typeface="Estrangelo Edessa"/>
+        <a:font script="Syrj" typeface="Estrangelo Edessa"/>
+        <a:font script="Syre" typeface="Estrangelo Edessa"/>
+        <a:font script="Sora" typeface="Nirmala UI"/>
+        <a:font script="Tale" typeface="Microsoft Tai Le"/>
+        <a:font script="Talu" typeface="Microsoft New Tai Lue"/>
+        <a:font script="Tfng" typeface="Ebrima"/>
+      </a:minorFont>
+    </a:fontScheme>
+    <a:fmtScheme name="Office">
+      <a:fillStyleLst>
+        <a:solidFill>
+          <a:schemeClr val="phClr"/>
+        </a:solidFill>
+        <a:gradFill rotWithShape="1">
+          <a:gsLst>
+            <a:gs pos="0">
+              <a:schemeClr val="phClr">
+                <a:lumMod val="110000"/>
+                <a:satMod val="105000"/>
+                <a:tint val="67000"/>
+              </a:schemeClr>
+            </a:gs>
+            <a:gs pos="50000">
+              <a:schemeClr val="phClr">
+                <a:lumMod val="105000"/>
+                <a:satMod val="103000"/>
+                <a:tint val="73000"/>
+              </a:schemeClr>
+            </a:gs>
+            <a:gs pos="100000">
+              <a:schemeClr val="phClr">
+                <a:lumMod val="105000"/>
+                <a:satMod val="109000"/>
+                <a:tint val="81000"/>
+              </a:schemeClr>
+            </a:gs>
+          </a:gsLst>
+          <a:lin ang="5400000" scaled="0"/>
+        </a:gradFill>
+        <a:gradFill rotWithShape="1">
+          <a:gsLst>
+            <a:gs pos="0">
+              <a:schemeClr val="phClr">
+                <a:satMod val="103000"/>
+                <a:lumMod val="102000"/>
+                <a:tint val="94000"/>
+              </a:schemeClr>
+            </a:gs>
+            <a:gs pos="50000">
+              <a:schemeClr val="phClr">
+                <a:satMod val="110000"/>
+                <a:lumMod val="100000"/>
+                <a:shade val="100000"/>
+              </a:schemeClr>
+            </a:gs>
+            <a:gs pos="100000">
+              <a:schemeClr val="phClr">
+                <a:lumMod val="99000"/>
+                <a:satMod val="120000"/>
+                <a:shade val="78000"/>
+              </a:schemeClr>
+            </a:gs>
+          </a:gsLst>
+          <a:lin ang="5400000" scaled="0"/>
+        </a:gradFill>
+      </a:fillStyleLst>
+      <a:lnStyleLst>
+        <a:ln w="12700" cap="flat" cmpd="sng" algn="ctr">
+          <a:solidFill>
+            <a:schemeClr val="phClr"/>
+          </a:solidFill>
+          <a:prstDash val="solid"/>
+          <a:miter lim="800000"/>
+        </a:ln>
+        <a:ln w="19050" cap="flat" cmpd="sng" algn="ctr">
+          <a:solidFill>
+            <a:schemeClr val="phClr"/>
+          </a:solidFill>
+          <a:prstDash val="solid"/>
+          <a:miter lim="800000"/>
+        </a:ln>
+        <a:ln w="25400" cap="flat" cmpd="sng" algn="ctr">
+          <a:solidFill>
+            <a:schemeClr val="phClr"/>
+          </a:solidFill>
+          <a:prstDash val="solid"/>
+          <a:miter lim="800000"/>
+        </a:ln>
+      </a:lnStyleLst>
+      <a:effectStyleLst>
+        <a:effectStyle>
+          <a:effectLst/>
+        </a:effectStyle>
+        <a:effectStyle>
+          <a:effectLst/>
+        </a:effectStyle>
+        <a:effectStyle>
+          <a:effectLst>
+            <a:outerShdw blurRad="57150" dist="19050" dir="5400000" algn="ctr" rotWithShape="0">
+              <a:srgbClr val="000000">
+                <a:alpha val="63000"/>
+              </a:srgbClr>
+            </a:outerShdw>
+          </a:effectLst>
+        </a:effectStyle>
+      </a:effectStyleLst>
+      <a:bgFillStyleLst>
+        <a:solidFill>
+          <a:schemeClr val="phClr"/>
+        </a:solidFill>
+        <a:solidFill>
+          <a:schemeClr val="phClr">
+            <a:tint val="95000"/>
+            <a:satMod val="170000"/>
+          </a:schemeClr>
+        </a:solidFill>
+        <a:gradFill rotWithShape="1">
+          <a:gsLst>
+            <a:gs pos="0">
+              <a:schemeClr val="phClr">
+                <a:tint val="93000"/>
+                <a:satMod val="150000"/>
+                <a:shade val="98000"/>
+                <a:lumMod val="102000"/>
+              </a:schemeClr>
+            </a:gs>
+            <a:gs pos="50000">
+              <a:schemeClr val="phClr">
+                <a:tint val="98000"/>
+                <a:satMod val="130000"/>
+                <a:shade val="90000"/>
+                <a:lumMod val="103000"/>
+              </a:schemeClr>
+            </a:gs>
+            <a:gs pos="100000">
+              <a:schemeClr val="phClr">
+                <a:shade val="63000"/>
+                <a:satMod val="120000"/>
+              </a:schemeClr>
+            </a:gs>
+          </a:gsLst>
+          <a:lin ang="5400000" scaled="0"/>
+        </a:gradFill>
+      </a:bgFillStyleLst>
+    </a:fmtScheme>
+  </a:themeElements>
+  <a:objectDefaults>
+    <a:lnDef>
+      <a:spPr/>
+      <a:bodyPr/>
+      <a:lstStyle/>
+      <a:style>
+        <a:lnRef idx="2">
+          <a:schemeClr val="accent1"/>
+        </a:lnRef>
+        <a:fillRef idx="0">
+          <a:schemeClr val="accent1"/>
+        </a:fillRef>
+        <a:effectRef idx="1">
+          <a:schemeClr val="accent1"/>
+        </a:effectRef>
+        <a:fontRef idx="minor">
+          <a:schemeClr val="tx1"/>
+        </a:fontRef>
+      </a:style>
+    </a:lnDef>
+  </a:objectDefaults>
+  <a:extraClrSchemeLst/>
+  <a:extLst>
+    <a:ext uri="{05A4C25C-085E-4340-85A3-A5531E510DB2}">
+      <thm15:themeFamily xmlns:thm15="http://schemas.microsoft.com/office/thememl/2012/main" name="Office Theme" id="{2E142A2C-CD16-42D6-873A-C26D2A0506FA}" vid="{1BDDFF52-6CD6-40A5-AB3C-68EB2F1E4D0A}"/>
+    </a:ext>
+  </a:extLst>
+</a:theme>
 </file>
</xml_diff>